<commit_message>
Expand project presentation details
</commit_message>
<xml_diff>
--- a/Mentoria_Compass_Mogger_Presentation.pptx
+++ b/Mentoria_Compass_Mogger_Presentation.pptx
@@ -12,6 +12,9 @@
     <p:sldId id="260" r:id="rId11"/>
     <p:sldId id="261" r:id="rId12"/>
     <p:sldId id="262" r:id="rId13"/>
+    <p:sldId id="263" r:id="rId14"/>
+    <p:sldId id="264" r:id="rId15"/>
+    <p:sldId id="265" r:id="rId16"/>
   </p:sldIdLst>
   <p:sldSz cx="12191695" cy="6858000" type="screen4x3"/>
   <p:notesSz cx="6858000" cy="9144000"/>
@@ -3153,8 +3156,8 @@
         </p:nvSpPr>
         <p:spPr>
           <a:xfrm>
-            <a:off x="9738360" y="411480"/>
-            <a:ext cx="1325880" cy="384048"/>
+            <a:off x="9464040" y="384048"/>
+            <a:ext cx="1920240" cy="438912"/>
           </a:xfrm>
           <a:prstGeom prst="rect">
             <a:avLst/>
@@ -3186,12 +3189,12 @@
           <a:p>
             <a:pPr algn="ctr"/>
             <a:r>
-              <a:rPr sz="1600" b="1">
+              <a:rPr sz="1300" b="1">
                 <a:solidFill>
                   <a:srgbClr val="0A0C0B"/>
                 </a:solidFill>
               </a:rPr>
-              <a:t>01</a:t>
+              <a:t>01 / Project</a:t>
             </a:r>
           </a:p>
         </p:txBody>
@@ -3204,8 +3207,8 @@
         </p:nvSpPr>
         <p:spPr>
           <a:xfrm>
-            <a:off x="658368" y="566928"/>
-            <a:ext cx="8869680" cy="502920"/>
+            <a:off x="685800" y="6446520"/>
+            <a:ext cx="10698480" cy="228600"/>
           </a:xfrm>
           <a:prstGeom prst="rect">
             <a:avLst/>
@@ -3219,12 +3222,12 @@
           <a:lstStyle/>
           <a:p>
             <a:r>
-              <a:rPr sz="1400" b="1">
-                <a:solidFill>
-                  <a:srgbClr val="DFFF55"/>
+              <a:rPr sz="850">
+                <a:solidFill>
+                  <a:srgbClr val="738472"/>
                 </a:solidFill>
               </a:rPr>
-              <a:t>MENTORIA COMPASS</a:t>
+              <a:t>https://mentoria-compass.vercel.app  |  https://github.com/askarshabdanov1-collab/Mentoria</a:t>
             </a:r>
           </a:p>
         </p:txBody>
@@ -3237,8 +3240,325 @@
         </p:nvSpPr>
         <p:spPr>
           <a:xfrm>
-            <a:off x="640080" y="932688"/>
-            <a:ext cx="10058400" cy="749808"/>
+            <a:off x="658368" y="530352"/>
+            <a:ext cx="8686800" cy="402336"/>
+          </a:xfrm>
+          <a:prstGeom prst="rect">
+            <a:avLst/>
+          </a:prstGeom>
+          <a:noFill/>
+        </p:spPr>
+        <p:txBody>
+          <a:bodyPr wrap="square">
+            <a:spAutoFit/>
+          </a:bodyPr>
+          <a:lstStyle/>
+          <a:p>
+            <a:r>
+              <a:rPr sz="1300" b="1">
+                <a:solidFill>
+                  <a:srgbClr val="DFFF55"/>
+                </a:solidFill>
+              </a:rPr>
+              <a:t>MENTORIA COMPASS / TEAM MOGGER</a:t>
+            </a:r>
+          </a:p>
+        </p:txBody>
+      </p:sp>
+      <p:sp>
+        <p:nvSpPr>
+          <p:cNvPr id="6" name="TextBox 5"/>
+          <p:cNvSpPr txBox="1"/>
+          <p:nvPr/>
+        </p:nvSpPr>
+        <p:spPr>
+          <a:xfrm>
+            <a:off x="640080" y="896112"/>
+            <a:ext cx="10195560" cy="749808"/>
+          </a:xfrm>
+          <a:prstGeom prst="rect">
+            <a:avLst/>
+          </a:prstGeom>
+          <a:noFill/>
+        </p:spPr>
+        <p:txBody>
+          <a:bodyPr wrap="square">
+            <a:spAutoFit/>
+          </a:bodyPr>
+          <a:lstStyle/>
+          <a:p>
+            <a:r>
+              <a:rPr sz="3800" b="1">
+                <a:solidFill>
+                  <a:srgbClr val="FFFEF0"/>
+                </a:solidFill>
+              </a:rPr>
+              <a:t>Mentoria Compass</a:t>
+            </a:r>
+          </a:p>
+        </p:txBody>
+      </p:sp>
+      <p:sp>
+        <p:nvSpPr>
+          <p:cNvPr id="7" name="TextBox 6"/>
+          <p:cNvSpPr txBox="1"/>
+          <p:nvPr/>
+        </p:nvSpPr>
+        <p:spPr>
+          <a:xfrm>
+            <a:off x="667512" y="1627632"/>
+            <a:ext cx="10241280" cy="411480"/>
+          </a:xfrm>
+          <a:prstGeom prst="rect">
+            <a:avLst/>
+          </a:prstGeom>
+          <a:noFill/>
+        </p:spPr>
+        <p:txBody>
+          <a:bodyPr wrap="square">
+            <a:spAutoFit/>
+          </a:bodyPr>
+          <a:lstStyle/>
+          <a:p>
+            <a:r>
+              <a:rPr sz="1700" b="0">
+                <a:solidFill>
+                  <a:srgbClr val="AAB8A9"/>
+                </a:solidFill>
+              </a:rPr>
+              <a:t>Full-stack EdTech hub for opportunities, async learning, AI roadmap and CV review</a:t>
+            </a:r>
+          </a:p>
+        </p:txBody>
+      </p:sp>
+      <p:sp>
+        <p:nvSpPr>
+          <p:cNvPr id="8" name="TextBox 7"/>
+          <p:cNvSpPr txBox="1"/>
+          <p:nvPr/>
+        </p:nvSpPr>
+        <p:spPr>
+          <a:xfrm>
+            <a:off x="685800" y="2148840"/>
+            <a:ext cx="10469880" cy="4224528"/>
+          </a:xfrm>
+          <a:prstGeom prst="rect">
+            <a:avLst/>
+          </a:prstGeom>
+          <a:noFill/>
+        </p:spPr>
+        <p:txBody>
+          <a:bodyPr wrap="square">
+            <a:spAutoFit/>
+          </a:bodyPr>
+          <a:lstStyle/>
+          <a:p>
+            <a:pPr>
+              <a:spcAft>
+                <a:spcPts val="700"/>
+              </a:spcAft>
+              <a:defRPr sz="1800">
+                <a:solidFill>
+                  <a:srgbClr val="E6EADA"/>
+                </a:solidFill>
+              </a:defRPr>
+            </a:pPr>
+            <a:r>
+              <a:t>Team: Mogger</a:t>
+            </a:r>
+          </a:p>
+          <a:p>
+            <a:pPr>
+              <a:spcAft>
+                <a:spcPts val="700"/>
+              </a:spcAft>
+              <a:defRPr sz="1800">
+                <a:solidFill>
+                  <a:srgbClr val="E6EADA"/>
+                </a:solidFill>
+              </a:defRPr>
+            </a:pPr>
+            <a:r>
+              <a:t>Captain: Shabdanov Askar / @LawDirr</a:t>
+            </a:r>
+          </a:p>
+          <a:p>
+            <a:pPr>
+              <a:spcAft>
+                <a:spcPts val="700"/>
+              </a:spcAft>
+              <a:defRPr sz="1800">
+                <a:solidFill>
+                  <a:srgbClr val="E6EADA"/>
+                </a:solidFill>
+              </a:defRPr>
+            </a:pPr>
+            <a:r>
+              <a:t>Production product: https://mentoria-compass.vercel.app</a:t>
+            </a:r>
+          </a:p>
+          <a:p>
+            <a:pPr>
+              <a:spcAft>
+                <a:spcPts val="700"/>
+              </a:spcAft>
+              <a:defRPr sz="1800">
+                <a:solidFill>
+                  <a:srgbClr val="E6EADA"/>
+                </a:solidFill>
+              </a:defRPr>
+            </a:pPr>
+            <a:r>
+              <a:t>GitHub repository: https://github.com/askarshabdanov1-collab/Mentoria</a:t>
+            </a:r>
+          </a:p>
+          <a:p>
+            <a:pPr>
+              <a:spcAft>
+                <a:spcPts val="700"/>
+              </a:spcAft>
+              <a:defRPr sz="1800">
+                <a:solidFill>
+                  <a:srgbClr val="E6EADA"/>
+                </a:solidFill>
+              </a:defRPr>
+            </a:pPr>
+            <a:r>
+              <a:t>Demo accounts: student amina@mentoria.demo / demo123, admin admin@mentoria.demo / admin123</a:t>
+            </a:r>
+          </a:p>
+        </p:txBody>
+      </p:sp>
+    </p:spTree>
+  </p:cSld>
+  <p:clrMapOvr>
+    <a:masterClrMapping/>
+  </p:clrMapOvr>
+</p:sld>
+</file>
+
+<file path=ppt/slides/slide10.xml><?xml version="1.0" encoding="utf-8"?>
+<p:sld xmlns:a="http://schemas.openxmlformats.org/drawingml/2006/main" xmlns:p="http://schemas.openxmlformats.org/presentationml/2006/main" xmlns:r="http://schemas.openxmlformats.org/officeDocument/2006/relationships">
+  <p:cSld>
+    <p:bg>
+      <p:bgPr>
+        <a:solidFill>
+          <a:srgbClr val="0A0C0B"/>
+        </a:solidFill>
+        <a:effectLst/>
+      </p:bgPr>
+    </p:bg>
+    <p:spTree>
+      <p:nvGrpSpPr>
+        <p:cNvPr id="1" name=""/>
+        <p:cNvGrpSpPr/>
+        <p:nvPr/>
+      </p:nvGrpSpPr>
+      <p:grpSpPr/>
+      <p:sp>
+        <p:nvSpPr>
+          <p:cNvPr id="2" name="Rectangle 1"/>
+          <p:cNvSpPr/>
+          <p:nvPr/>
+        </p:nvSpPr>
+        <p:spPr>
+          <a:xfrm>
+            <a:off x="0" y="0"/>
+            <a:ext cx="12191695" cy="109728"/>
+          </a:xfrm>
+          <a:prstGeom prst="rect">
+            <a:avLst/>
+          </a:prstGeom>
+          <a:solidFill>
+            <a:srgbClr val="DFFF55"/>
+          </a:solidFill>
+          <a:ln>
+            <a:noFill/>
+          </a:ln>
+        </p:spPr>
+        <p:style>
+          <a:lnRef idx="1">
+            <a:schemeClr val="accent1"/>
+          </a:lnRef>
+          <a:fillRef idx="3">
+            <a:schemeClr val="accent1"/>
+          </a:fillRef>
+          <a:effectRef idx="2">
+            <a:schemeClr val="accent1"/>
+          </a:effectRef>
+          <a:fontRef idx="minor">
+            <a:schemeClr val="lt1"/>
+          </a:fontRef>
+        </p:style>
+        <p:txBody>
+          <a:bodyPr rtlCol="0" anchor="ctr"/>
+          <a:lstStyle/>
+          <a:p>
+            <a:pPr algn="ctr"/>
+          </a:p>
+        </p:txBody>
+      </p:sp>
+      <p:sp>
+        <p:nvSpPr>
+          <p:cNvPr id="3" name="Rectangle 2"/>
+          <p:cNvSpPr/>
+          <p:nvPr/>
+        </p:nvSpPr>
+        <p:spPr>
+          <a:xfrm>
+            <a:off x="9464040" y="384048"/>
+            <a:ext cx="1920240" cy="438912"/>
+          </a:xfrm>
+          <a:prstGeom prst="rect">
+            <a:avLst/>
+          </a:prstGeom>
+          <a:solidFill>
+            <a:srgbClr val="5AD7FF"/>
+          </a:solidFill>
+          <a:ln>
+            <a:noFill/>
+          </a:ln>
+        </p:spPr>
+        <p:style>
+          <a:lnRef idx="1">
+            <a:schemeClr val="accent1"/>
+          </a:lnRef>
+          <a:fillRef idx="3">
+            <a:schemeClr val="accent1"/>
+          </a:fillRef>
+          <a:effectRef idx="2">
+            <a:schemeClr val="accent1"/>
+          </a:effectRef>
+          <a:fontRef idx="minor">
+            <a:schemeClr val="lt1"/>
+          </a:fontRef>
+        </p:style>
+        <p:txBody>
+          <a:bodyPr rtlCol="0" anchor="ctr"/>
+          <a:lstStyle/>
+          <a:p>
+            <a:pPr algn="ctr"/>
+            <a:r>
+              <a:rPr sz="1300" b="1">
+                <a:solidFill>
+                  <a:srgbClr val="0A0C0B"/>
+                </a:solidFill>
+              </a:rPr>
+              <a:t>10 / Roadmap</a:t>
+            </a:r>
+          </a:p>
+        </p:txBody>
+      </p:sp>
+      <p:sp>
+        <p:nvSpPr>
+          <p:cNvPr id="4" name="TextBox 3"/>
+          <p:cNvSpPr txBox="1"/>
+          <p:nvPr/>
+        </p:nvSpPr>
+        <p:spPr>
+          <a:xfrm>
+            <a:off x="685800" y="6446520"/>
+            <a:ext cx="10698480" cy="228600"/>
           </a:xfrm>
           <a:prstGeom prst="rect">
             <a:avLst/>
@@ -3252,12 +3572,45 @@
           <a:lstStyle/>
           <a:p>
             <a:r>
-              <a:rPr sz="4200" b="1">
-                <a:solidFill>
-                  <a:srgbClr val="FFFEF0"/>
+              <a:rPr sz="850">
+                <a:solidFill>
+                  <a:srgbClr val="738472"/>
                 </a:solidFill>
               </a:rPr>
-              <a:t>Mentoria Compass</a:t>
+              <a:t>https://mentoria-compass.vercel.app  |  https://github.com/askarshabdanov1-collab/Mentoria</a:t>
+            </a:r>
+          </a:p>
+        </p:txBody>
+      </p:sp>
+      <p:sp>
+        <p:nvSpPr>
+          <p:cNvPr id="5" name="TextBox 4"/>
+          <p:cNvSpPr txBox="1"/>
+          <p:nvPr/>
+        </p:nvSpPr>
+        <p:spPr>
+          <a:xfrm>
+            <a:off x="658368" y="530352"/>
+            <a:ext cx="8686800" cy="402336"/>
+          </a:xfrm>
+          <a:prstGeom prst="rect">
+            <a:avLst/>
+          </a:prstGeom>
+          <a:noFill/>
+        </p:spPr>
+        <p:txBody>
+          <a:bodyPr wrap="square">
+            <a:spAutoFit/>
+          </a:bodyPr>
+          <a:lstStyle/>
+          <a:p>
+            <a:r>
+              <a:rPr sz="1300" b="1">
+                <a:solidFill>
+                  <a:srgbClr val="DFFF55"/>
+                </a:solidFill>
+              </a:rPr>
+              <a:t>MENTORIA COMPASS / TEAM MOGGER</a:t>
             </a:r>
           </a:p>
         </p:txBody>
@@ -3270,8 +3623,8 @@
         </p:nvSpPr>
         <p:spPr>
           <a:xfrm>
-            <a:off x="667512" y="1664208"/>
-            <a:ext cx="10241280" cy="411480"/>
+            <a:off x="640080" y="896112"/>
+            <a:ext cx="10195560" cy="749808"/>
           </a:xfrm>
           <a:prstGeom prst="rect">
             <a:avLst/>
@@ -3279,18 +3632,18 @@
           <a:noFill/>
         </p:spPr>
         <p:txBody>
-          <a:bodyPr wrap="none">
+          <a:bodyPr wrap="square">
             <a:spAutoFit/>
           </a:bodyPr>
           <a:lstStyle/>
           <a:p>
             <a:r>
-              <a:rPr sz="1800" b="0">
-                <a:solidFill>
-                  <a:srgbClr val="AAB8A9"/>
+              <a:rPr sz="3800" b="1">
+                <a:solidFill>
+                  <a:srgbClr val="FFFEF0"/>
                 </a:solidFill>
               </a:rPr>
-              <a:t>Personalized EdTech hub for opportunities, async learning, AI roadmap and CV review</a:t>
+              <a:t>What Comes Next</a:t>
             </a:r>
           </a:p>
         </p:txBody>
@@ -3303,8 +3656,8 @@
         </p:nvSpPr>
         <p:spPr>
           <a:xfrm>
-            <a:off x="685800" y="2148840"/>
-            <a:ext cx="10424160" cy="3931920"/>
+            <a:off x="667512" y="1627632"/>
+            <a:ext cx="10241280" cy="411480"/>
           </a:xfrm>
           <a:prstGeom prst="rect">
             <a:avLst/>
@@ -3312,68 +3665,131 @@
           <a:noFill/>
         </p:spPr>
         <p:txBody>
-          <a:bodyPr wrap="none">
+          <a:bodyPr wrap="square">
             <a:spAutoFit/>
           </a:bodyPr>
           <a:lstStyle/>
           <a:p>
+            <a:r>
+              <a:rPr sz="1700" b="0">
+                <a:solidFill>
+                  <a:srgbClr val="AAB8A9"/>
+                </a:solidFill>
+              </a:rPr>
+              <a:t>Clear path from hackathon MVP to real Mentoria product</a:t>
+            </a:r>
+          </a:p>
+        </p:txBody>
+      </p:sp>
+      <p:sp>
+        <p:nvSpPr>
+          <p:cNvPr id="8" name="TextBox 7"/>
+          <p:cNvSpPr txBox="1"/>
+          <p:nvPr/>
+        </p:nvSpPr>
+        <p:spPr>
+          <a:xfrm>
+            <a:off x="685800" y="2148840"/>
+            <a:ext cx="10469880" cy="4224528"/>
+          </a:xfrm>
+          <a:prstGeom prst="rect">
+            <a:avLst/>
+          </a:prstGeom>
+          <a:noFill/>
+        </p:spPr>
+        <p:txBody>
+          <a:bodyPr wrap="square">
+            <a:spAutoFit/>
+          </a:bodyPr>
+          <a:lstStyle/>
+          <a:p>
             <a:pPr>
               <a:spcAft>
-                <a:spcPts val="800"/>
+                <a:spcPts val="700"/>
               </a:spcAft>
-              <a:defRPr sz="1900">
+              <a:defRPr sz="1700">
                 <a:solidFill>
                   <a:srgbClr val="E6EADA"/>
                 </a:solidFill>
               </a:defRPr>
             </a:pPr>
             <a:r>
-              <a:t>Team: Mogger</a:t>
+              <a:t>Connect persistent production database: Supabase or Neon Postgres.</a:t>
             </a:r>
           </a:p>
           <a:p>
             <a:pPr>
               <a:spcAft>
-                <a:spcPts val="800"/>
+                <a:spcPts val="700"/>
               </a:spcAft>
-              <a:defRPr sz="1900">
+              <a:defRPr sz="1700">
                 <a:solidFill>
                   <a:srgbClr val="E6EADA"/>
                 </a:solidFill>
               </a:defRPr>
             </a:pPr>
             <a:r>
-              <a:t>Captain: Shabdanov Askar / @LawDirr</a:t>
+              <a:t>Add Telegram/email reminders for saved opportunity deadlines.</a:t>
             </a:r>
           </a:p>
           <a:p>
             <a:pPr>
               <a:spcAft>
-                <a:spcPts val="800"/>
+                <a:spcPts val="700"/>
               </a:spcAft>
-              <a:defRPr sz="1900">
+              <a:defRPr sz="1700">
                 <a:solidFill>
                   <a:srgbClr val="E6EADA"/>
                 </a:solidFill>
               </a:defRPr>
             </a:pPr>
             <a:r>
-              <a:t>Product: https://mentoria-compass.vercel.app</a:t>
+              <a:t>Add mentor portal for uploading lessons, checking assignments and leaving feedback.</a:t>
             </a:r>
           </a:p>
           <a:p>
             <a:pPr>
               <a:spcAft>
-                <a:spcPts val="800"/>
+                <a:spcPts val="700"/>
               </a:spcAft>
-              <a:defRPr sz="1900">
+              <a:defRPr sz="1700">
                 <a:solidFill>
                   <a:srgbClr val="E6EADA"/>
                 </a:solidFill>
               </a:defRPr>
             </a:pPr>
             <a:r>
-              <a:t>GitHub: https://github.com/askarshabdanov1-collab/Mentoria</a:t>
+              <a:t>Add multilingual interface: Russian, English and Kazakh.</a:t>
+            </a:r>
+          </a:p>
+          <a:p>
+            <a:pPr>
+              <a:spcAft>
+                <a:spcPts val="700"/>
+              </a:spcAft>
+              <a:defRPr sz="1700">
+                <a:solidFill>
+                  <a:srgbClr val="E6EADA"/>
+                </a:solidFill>
+              </a:defRPr>
+            </a:pPr>
+            <a:r>
+              <a:t>Add certificates, leaderboard and advanced roadmap for grades 8, 9, 10 and 11.</a:t>
+            </a:r>
+          </a:p>
+          <a:p>
+            <a:pPr>
+              <a:spcAft>
+                <a:spcPts val="700"/>
+              </a:spcAft>
+              <a:defRPr sz="1700">
+                <a:solidFill>
+                  <a:srgbClr val="E6EADA"/>
+                </a:solidFill>
+              </a:defRPr>
+            </a:pPr>
+            <a:r>
+              <a:t>Add real AI integration for deeper CV and essay review when API keys are available.</a:t>
             </a:r>
           </a:p>
         </p:txBody>
@@ -3455,8 +3871,8 @@
         </p:nvSpPr>
         <p:spPr>
           <a:xfrm>
-            <a:off x="9738360" y="411480"/>
-            <a:ext cx="1325880" cy="384048"/>
+            <a:off x="9464040" y="384048"/>
+            <a:ext cx="1920240" cy="438912"/>
           </a:xfrm>
           <a:prstGeom prst="rect">
             <a:avLst/>
@@ -3488,12 +3904,12 @@
           <a:p>
             <a:pPr algn="ctr"/>
             <a:r>
-              <a:rPr sz="1600" b="1">
+              <a:rPr sz="1300" b="1">
                 <a:solidFill>
                   <a:srgbClr val="0A0C0B"/>
                 </a:solidFill>
               </a:rPr>
-              <a:t>02</a:t>
+              <a:t>02 / Problem</a:t>
             </a:r>
           </a:p>
         </p:txBody>
@@ -3506,8 +3922,8 @@
         </p:nvSpPr>
         <p:spPr>
           <a:xfrm>
-            <a:off x="658368" y="566928"/>
-            <a:ext cx="8869680" cy="502920"/>
+            <a:off x="685800" y="6446520"/>
+            <a:ext cx="10698480" cy="228600"/>
           </a:xfrm>
           <a:prstGeom prst="rect">
             <a:avLst/>
@@ -3521,12 +3937,12 @@
           <a:lstStyle/>
           <a:p>
             <a:r>
-              <a:rPr sz="1400" b="1">
-                <a:solidFill>
-                  <a:srgbClr val="DFFF55"/>
+              <a:rPr sz="850">
+                <a:solidFill>
+                  <a:srgbClr val="738472"/>
                 </a:solidFill>
               </a:rPr>
-              <a:t>MENTORIA COMPASS</a:t>
+              <a:t>https://mentoria-compass.vercel.app  |  https://github.com/askarshabdanov1-collab/Mentoria</a:t>
             </a:r>
           </a:p>
         </p:txBody>
@@ -3539,8 +3955,8 @@
         </p:nvSpPr>
         <p:spPr>
           <a:xfrm>
-            <a:off x="640080" y="932688"/>
-            <a:ext cx="10058400" cy="749808"/>
+            <a:off x="658368" y="530352"/>
+            <a:ext cx="8686800" cy="402336"/>
           </a:xfrm>
           <a:prstGeom prst="rect">
             <a:avLst/>
@@ -3548,18 +3964,18 @@
           <a:noFill/>
         </p:spPr>
         <p:txBody>
-          <a:bodyPr wrap="none">
+          <a:bodyPr wrap="square">
             <a:spAutoFit/>
           </a:bodyPr>
           <a:lstStyle/>
           <a:p>
             <a:r>
-              <a:rPr sz="4200" b="1">
-                <a:solidFill>
-                  <a:srgbClr val="FFFEF0"/>
+              <a:rPr sz="1300" b="1">
+                <a:solidFill>
+                  <a:srgbClr val="DFFF55"/>
                 </a:solidFill>
               </a:rPr>
-              <a:t>Problem</a:t>
+              <a:t>MENTORIA COMPASS / TEAM MOGGER</a:t>
             </a:r>
           </a:p>
         </p:txBody>
@@ -3572,8 +3988,8 @@
         </p:nvSpPr>
         <p:spPr>
           <a:xfrm>
-            <a:off x="667512" y="1664208"/>
-            <a:ext cx="10241280" cy="411480"/>
+            <a:off x="640080" y="896112"/>
+            <a:ext cx="10195560" cy="749808"/>
           </a:xfrm>
           <a:prstGeom prst="rect">
             <a:avLst/>
@@ -3581,18 +3997,18 @@
           <a:noFill/>
         </p:spPr>
         <p:txBody>
-          <a:bodyPr wrap="none">
+          <a:bodyPr wrap="square">
             <a:spAutoFit/>
           </a:bodyPr>
           <a:lstStyle/>
           <a:p>
             <a:r>
-              <a:rPr sz="1800" b="0">
-                <a:solidFill>
-                  <a:srgbClr val="AAB8A9"/>
+              <a:rPr sz="3800" b="1">
+                <a:solidFill>
+                  <a:srgbClr val="FFFEF0"/>
                 </a:solidFill>
               </a:rPr>
-              <a:t>Mentoria is growing beyond Telegram and live calls</a:t>
+              <a:t>Why Mentoria Needs a Platform</a:t>
             </a:r>
           </a:p>
         </p:txBody>
@@ -3605,8 +4021,8 @@
         </p:nvSpPr>
         <p:spPr>
           <a:xfrm>
-            <a:off x="685800" y="2148840"/>
-            <a:ext cx="10424160" cy="3931920"/>
+            <a:off x="667512" y="1627632"/>
+            <a:ext cx="10241280" cy="411480"/>
           </a:xfrm>
           <a:prstGeom prst="rect">
             <a:avLst/>
@@ -3614,68 +4030,116 @@
           <a:noFill/>
         </p:spPr>
         <p:txBody>
-          <a:bodyPr wrap="none">
+          <a:bodyPr wrap="square">
             <a:spAutoFit/>
           </a:bodyPr>
           <a:lstStyle/>
           <a:p>
+            <a:r>
+              <a:rPr sz="1700" b="0">
+                <a:solidFill>
+                  <a:srgbClr val="AAB8A9"/>
+                </a:solidFill>
+              </a:rPr>
+              <a:t>Telegram and live calls are not enough when the organization grows</a:t>
+            </a:r>
+          </a:p>
+        </p:txBody>
+      </p:sp>
+      <p:sp>
+        <p:nvSpPr>
+          <p:cNvPr id="8" name="TextBox 7"/>
+          <p:cNvSpPr txBox="1"/>
+          <p:nvPr/>
+        </p:nvSpPr>
+        <p:spPr>
+          <a:xfrm>
+            <a:off x="685800" y="2148840"/>
+            <a:ext cx="10469880" cy="4224528"/>
+          </a:xfrm>
+          <a:prstGeom prst="rect">
+            <a:avLst/>
+          </a:prstGeom>
+          <a:noFill/>
+        </p:spPr>
+        <p:txBody>
+          <a:bodyPr wrap="square">
+            <a:spAutoFit/>
+          </a:bodyPr>
+          <a:lstStyle/>
+          <a:p>
             <a:pPr>
               <a:spcAft>
-                <a:spcPts val="800"/>
+                <a:spcPts val="700"/>
               </a:spcAft>
-              <a:defRPr sz="1900">
+              <a:defRPr sz="1800">
                 <a:solidFill>
                   <a:srgbClr val="E6EADA"/>
                 </a:solidFill>
               </a:defRPr>
             </a:pPr>
             <a:r>
-              <a:t>Students miss live lessons because of school, exams, time zones and unstable schedules.</a:t>
+              <a:t>Students miss live lessons because of school, exams, time zones, internet access and personal schedules.</a:t>
             </a:r>
           </a:p>
           <a:p>
             <a:pPr>
               <a:spcAft>
-                <a:spcPts val="800"/>
+                <a:spcPts val="700"/>
               </a:spcAft>
-              <a:defRPr sz="1900">
+              <a:defRPr sz="1800">
                 <a:solidFill>
                   <a:srgbClr val="E6EADA"/>
                 </a:solidFill>
               </a:defRPr>
             </a:pPr>
             <a:r>
-              <a:t>Opportunities are scattered across sites, channels, chats and documents.</a:t>
+              <a:t>Opportunities are scattered across websites, Telegram channels, chats and documents.</a:t>
             </a:r>
           </a:p>
           <a:p>
             <a:pPr>
               <a:spcAft>
-                <a:spcPts val="800"/>
+                <a:spcPts val="700"/>
               </a:spcAft>
-              <a:defRPr sz="1900">
+              <a:defRPr sz="1800">
                 <a:solidFill>
                   <a:srgbClr val="E6EADA"/>
                 </a:solidFill>
               </a:defRPr>
             </a:pPr>
             <a:r>
-              <a:t>Students do not know which programs fit their grade, interests and goals.</a:t>
+              <a:t>Students do not know which competitions, scholarships or programs match their grade, interests and goals.</a:t>
             </a:r>
           </a:p>
           <a:p>
             <a:pPr>
               <a:spcAft>
-                <a:spcPts val="800"/>
+                <a:spcPts val="700"/>
               </a:spcAft>
-              <a:defRPr sz="1900">
+              <a:defRPr sz="1800">
                 <a:solidFill>
                   <a:srgbClr val="E6EADA"/>
                 </a:solidFill>
               </a:defRPr>
             </a:pPr>
             <a:r>
-              <a:t>Mentoria needs a scalable system for courses, recommendations and student retention.</a:t>
+              <a:t>Mentoria admins need to add courses and opportunities without rebuilding the website or posting manually.</a:t>
+            </a:r>
+          </a:p>
+          <a:p>
+            <a:pPr>
+              <a:spcAft>
+                <a:spcPts val="700"/>
+              </a:spcAft>
+              <a:defRPr sz="1800">
+                <a:solidFill>
+                  <a:srgbClr val="E6EADA"/>
+                </a:solidFill>
+              </a:defRPr>
+            </a:pPr>
+            <a:r>
+              <a:t>Partners, schools and sponsors need to see a professional scalable product, not only a chat community.</a:t>
             </a:r>
           </a:p>
         </p:txBody>
@@ -3757,8 +4221,8 @@
         </p:nvSpPr>
         <p:spPr>
           <a:xfrm>
-            <a:off x="9738360" y="411480"/>
-            <a:ext cx="1325880" cy="384048"/>
+            <a:off x="9464040" y="384048"/>
+            <a:ext cx="1920240" cy="438912"/>
           </a:xfrm>
           <a:prstGeom prst="rect">
             <a:avLst/>
@@ -3790,12 +4254,12 @@
           <a:p>
             <a:pPr algn="ctr"/>
             <a:r>
-              <a:rPr sz="1600" b="1">
+              <a:rPr sz="1300" b="1">
                 <a:solidFill>
                   <a:srgbClr val="0A0C0B"/>
                 </a:solidFill>
               </a:rPr>
-              <a:t>03</a:t>
+              <a:t>03 / Audience</a:t>
             </a:r>
           </a:p>
         </p:txBody>
@@ -3808,8 +4272,8 @@
         </p:nvSpPr>
         <p:spPr>
           <a:xfrm>
-            <a:off x="658368" y="566928"/>
-            <a:ext cx="8869680" cy="502920"/>
+            <a:off x="685800" y="6446520"/>
+            <a:ext cx="10698480" cy="228600"/>
           </a:xfrm>
           <a:prstGeom prst="rect">
             <a:avLst/>
@@ -3823,12 +4287,12 @@
           <a:lstStyle/>
           <a:p>
             <a:r>
-              <a:rPr sz="1400" b="1">
-                <a:solidFill>
-                  <a:srgbClr val="DFFF55"/>
+              <a:rPr sz="850">
+                <a:solidFill>
+                  <a:srgbClr val="738472"/>
                 </a:solidFill>
               </a:rPr>
-              <a:t>MENTORIA COMPASS</a:t>
+              <a:t>https://mentoria-compass.vercel.app  |  https://github.com/askarshabdanov1-collab/Mentoria</a:t>
             </a:r>
           </a:p>
         </p:txBody>
@@ -3841,8 +4305,8 @@
         </p:nvSpPr>
         <p:spPr>
           <a:xfrm>
-            <a:off x="640080" y="932688"/>
-            <a:ext cx="10058400" cy="749808"/>
+            <a:off x="658368" y="530352"/>
+            <a:ext cx="8686800" cy="402336"/>
           </a:xfrm>
           <a:prstGeom prst="rect">
             <a:avLst/>
@@ -3850,18 +4314,18 @@
           <a:noFill/>
         </p:spPr>
         <p:txBody>
-          <a:bodyPr wrap="none">
+          <a:bodyPr wrap="square">
             <a:spAutoFit/>
           </a:bodyPr>
           <a:lstStyle/>
           <a:p>
             <a:r>
-              <a:rPr sz="4200" b="1">
-                <a:solidFill>
-                  <a:srgbClr val="FFFEF0"/>
+              <a:rPr sz="1300" b="1">
+                <a:solidFill>
+                  <a:srgbClr val="DFFF55"/>
                 </a:solidFill>
               </a:rPr>
-              <a:t>Solution</a:t>
+              <a:t>MENTORIA COMPASS / TEAM MOGGER</a:t>
             </a:r>
           </a:p>
         </p:txBody>
@@ -3874,8 +4338,8 @@
         </p:nvSpPr>
         <p:spPr>
           <a:xfrm>
-            <a:off x="667512" y="1664208"/>
-            <a:ext cx="10241280" cy="411480"/>
+            <a:off x="640080" y="896112"/>
+            <a:ext cx="10195560" cy="749808"/>
           </a:xfrm>
           <a:prstGeom prst="rect">
             <a:avLst/>
@@ -3883,18 +4347,18 @@
           <a:noFill/>
         </p:spPr>
         <p:txBody>
-          <a:bodyPr wrap="none">
+          <a:bodyPr wrap="square">
             <a:spAutoFit/>
           </a:bodyPr>
           <a:lstStyle/>
           <a:p>
             <a:r>
-              <a:rPr sz="1800" b="0">
-                <a:solidFill>
-                  <a:srgbClr val="AAB8A9"/>
+              <a:rPr sz="3800" b="1">
+                <a:solidFill>
+                  <a:srgbClr val="FFFEF0"/>
                 </a:solidFill>
               </a:rPr>
-              <a:t>One platform for opportunities, courses and personal progress</a:t>
+              <a:t>Who the Product Is For</a:t>
             </a:r>
           </a:p>
         </p:txBody>
@@ -3907,8 +4371,8 @@
         </p:nvSpPr>
         <p:spPr>
           <a:xfrm>
-            <a:off x="685800" y="2148840"/>
-            <a:ext cx="10424160" cy="3931920"/>
+            <a:off x="667512" y="1627632"/>
+            <a:ext cx="10241280" cy="411480"/>
           </a:xfrm>
           <a:prstGeom prst="rect">
             <a:avLst/>
@@ -3916,68 +4380,101 @@
           <a:noFill/>
         </p:spPr>
         <p:txBody>
-          <a:bodyPr wrap="none">
+          <a:bodyPr wrap="square">
             <a:spAutoFit/>
           </a:bodyPr>
           <a:lstStyle/>
           <a:p>
+            <a:r>
+              <a:rPr sz="1700" b="0">
+                <a:solidFill>
+                  <a:srgbClr val="AAB8A9"/>
+                </a:solidFill>
+              </a:rPr>
+              <a:t>Students in grades 8-11 preparing for growth beyond school</a:t>
+            </a:r>
+          </a:p>
+        </p:txBody>
+      </p:sp>
+      <p:sp>
+        <p:nvSpPr>
+          <p:cNvPr id="8" name="TextBox 7"/>
+          <p:cNvSpPr txBox="1"/>
+          <p:nvPr/>
+        </p:nvSpPr>
+        <p:spPr>
+          <a:xfrm>
+            <a:off x="685800" y="2148840"/>
+            <a:ext cx="10469880" cy="4224528"/>
+          </a:xfrm>
+          <a:prstGeom prst="rect">
+            <a:avLst/>
+          </a:prstGeom>
+          <a:noFill/>
+        </p:spPr>
+        <p:txBody>
+          <a:bodyPr wrap="square">
+            <a:spAutoFit/>
+          </a:bodyPr>
+          <a:lstStyle/>
+          <a:p>
             <a:pPr>
               <a:spcAft>
-                <a:spcPts val="800"/>
+                <a:spcPts val="700"/>
               </a:spcAft>
-              <a:defRPr sz="1900">
+              <a:defRPr sz="1800">
                 <a:solidFill>
                   <a:srgbClr val="E6EADA"/>
                 </a:solidFill>
               </a:defRPr>
             </a:pPr>
             <a:r>
-              <a:t>Registration and personal student cabinet with saved opportunities and course progress.</a:t>
+              <a:t>Students from Kazakhstan and other countries who want academic and extracurricular opportunities.</a:t>
             </a:r>
           </a:p>
           <a:p>
             <a:pPr>
               <a:spcAft>
-                <a:spcPts val="800"/>
+                <a:spcPts val="700"/>
               </a:spcAft>
-              <a:defRPr sz="1900">
+              <a:defRPr sz="1800">
                 <a:solidFill>
                   <a:srgbClr val="E6EADA"/>
                 </a:solidFill>
               </a:defRPr>
             </a:pPr>
             <a:r>
-              <a:t>Opportunity catalog with filters, search and profile match score.</a:t>
+              <a:t>Students preparing for university admissions, IELTS/SAT, scholarships and international programs.</a:t>
             </a:r>
           </a:p>
           <a:p>
             <a:pPr>
               <a:spcAft>
-                <a:spcPts val="800"/>
+                <a:spcPts val="700"/>
               </a:spcAft>
-              <a:defRPr sz="1900">
+              <a:defRPr sz="1800">
                 <a:solidFill>
                   <a:srgbClr val="E6EADA"/>
                 </a:solidFill>
               </a:defRPr>
             </a:pPr>
             <a:r>
-              <a:t>Async Mentoria courses with lessons, tasks and completion tracking.</a:t>
+              <a:t>Students interested in STEM, business, finance, social impact, programming, science and English.</a:t>
             </a:r>
           </a:p>
           <a:p>
             <a:pPr>
               <a:spcAft>
-                <a:spcPts val="800"/>
+                <a:spcPts val="700"/>
               </a:spcAft>
-              <a:defRPr sz="1900">
+              <a:defRPr sz="1800">
                 <a:solidFill>
                   <a:srgbClr val="E6EADA"/>
                 </a:solidFill>
               </a:defRPr>
             </a:pPr>
             <a:r>
-              <a:t>Admin panel for adding opportunities/courses without rebuilding the website.</a:t>
+              <a:t>Mentoria admins and mentors who need one place to manage learning content and student progress.</a:t>
             </a:r>
           </a:p>
         </p:txBody>
@@ -4059,8 +4556,8 @@
         </p:nvSpPr>
         <p:spPr>
           <a:xfrm>
-            <a:off x="9738360" y="411480"/>
-            <a:ext cx="1325880" cy="384048"/>
+            <a:off x="9464040" y="384048"/>
+            <a:ext cx="1920240" cy="438912"/>
           </a:xfrm>
           <a:prstGeom prst="rect">
             <a:avLst/>
@@ -4092,12 +4589,12 @@
           <a:p>
             <a:pPr algn="ctr"/>
             <a:r>
-              <a:rPr sz="1600" b="1">
+              <a:rPr sz="1300" b="1">
                 <a:solidFill>
                   <a:srgbClr val="0A0C0B"/>
                 </a:solidFill>
               </a:rPr>
-              <a:t>04</a:t>
+              <a:t>04 / Solution</a:t>
             </a:r>
           </a:p>
         </p:txBody>
@@ -4110,8 +4607,8 @@
         </p:nvSpPr>
         <p:spPr>
           <a:xfrm>
-            <a:off x="658368" y="566928"/>
-            <a:ext cx="8869680" cy="502920"/>
+            <a:off x="685800" y="6446520"/>
+            <a:ext cx="10698480" cy="228600"/>
           </a:xfrm>
           <a:prstGeom prst="rect">
             <a:avLst/>
@@ -4125,12 +4622,12 @@
           <a:lstStyle/>
           <a:p>
             <a:r>
-              <a:rPr sz="1400" b="1">
-                <a:solidFill>
-                  <a:srgbClr val="DFFF55"/>
+              <a:rPr sz="850">
+                <a:solidFill>
+                  <a:srgbClr val="738472"/>
                 </a:solidFill>
               </a:rPr>
-              <a:t>MENTORIA COMPASS</a:t>
+              <a:t>https://mentoria-compass.vercel.app  |  https://github.com/askarshabdanov1-collab/Mentoria</a:t>
             </a:r>
           </a:p>
         </p:txBody>
@@ -4143,8 +4640,8 @@
         </p:nvSpPr>
         <p:spPr>
           <a:xfrm>
-            <a:off x="640080" y="932688"/>
-            <a:ext cx="10058400" cy="749808"/>
+            <a:off x="658368" y="530352"/>
+            <a:ext cx="8686800" cy="402336"/>
           </a:xfrm>
           <a:prstGeom prst="rect">
             <a:avLst/>
@@ -4152,18 +4649,18 @@
           <a:noFill/>
         </p:spPr>
         <p:txBody>
-          <a:bodyPr wrap="none">
+          <a:bodyPr wrap="square">
             <a:spAutoFit/>
           </a:bodyPr>
           <a:lstStyle/>
           <a:p>
             <a:r>
-              <a:rPr sz="4200" b="1">
-                <a:solidFill>
-                  <a:srgbClr val="FFFEF0"/>
+              <a:rPr sz="1300" b="1">
+                <a:solidFill>
+                  <a:srgbClr val="DFFF55"/>
                 </a:solidFill>
               </a:rPr>
-              <a:t>AI Features</a:t>
+              <a:t>MENTORIA COMPASS / TEAM MOGGER</a:t>
             </a:r>
           </a:p>
         </p:txBody>
@@ -4176,8 +4673,8 @@
         </p:nvSpPr>
         <p:spPr>
           <a:xfrm>
-            <a:off x="667512" y="1664208"/>
-            <a:ext cx="10241280" cy="411480"/>
+            <a:off x="640080" y="896112"/>
+            <a:ext cx="10195560" cy="749808"/>
           </a:xfrm>
           <a:prstGeom prst="rect">
             <a:avLst/>
@@ -4185,18 +4682,18 @@
           <a:noFill/>
         </p:spPr>
         <p:txBody>
-          <a:bodyPr wrap="none">
+          <a:bodyPr wrap="square">
             <a:spAutoFit/>
           </a:bodyPr>
           <a:lstStyle/>
           <a:p>
             <a:r>
-              <a:rPr sz="1800" b="0">
-                <a:solidFill>
-                  <a:srgbClr val="AAB8A9"/>
+              <a:rPr sz="3800" b="1">
+                <a:solidFill>
+                  <a:srgbClr val="FFFEF0"/>
                 </a:solidFill>
               </a:rPr>
-              <a:t>AI-style analysis that works without external API keys</a:t>
+              <a:t>What Mentoria Compass Does</a:t>
             </a:r>
           </a:p>
         </p:txBody>
@@ -4209,8 +4706,8 @@
         </p:nvSpPr>
         <p:spPr>
           <a:xfrm>
-            <a:off x="685800" y="2148840"/>
-            <a:ext cx="10424160" cy="3931920"/>
+            <a:off x="667512" y="1627632"/>
+            <a:ext cx="10241280" cy="411480"/>
           </a:xfrm>
           <a:prstGeom prst="rect">
             <a:avLst/>
@@ -4218,68 +4715,116 @@
           <a:noFill/>
         </p:spPr>
         <p:txBody>
-          <a:bodyPr wrap="none">
+          <a:bodyPr wrap="square">
             <a:spAutoFit/>
           </a:bodyPr>
           <a:lstStyle/>
           <a:p>
+            <a:r>
+              <a:rPr sz="1700" b="0">
+                <a:solidFill>
+                  <a:srgbClr val="AAB8A9"/>
+                </a:solidFill>
+              </a:rPr>
+              <a:t>One product connecting discovery, learning, progress and applications</a:t>
+            </a:r>
+          </a:p>
+        </p:txBody>
+      </p:sp>
+      <p:sp>
+        <p:nvSpPr>
+          <p:cNvPr id="8" name="TextBox 7"/>
+          <p:cNvSpPr txBox="1"/>
+          <p:nvPr/>
+        </p:nvSpPr>
+        <p:spPr>
+          <a:xfrm>
+            <a:off x="685800" y="2148840"/>
+            <a:ext cx="10469880" cy="4224528"/>
+          </a:xfrm>
+          <a:prstGeom prst="rect">
+            <a:avLst/>
+          </a:prstGeom>
+          <a:noFill/>
+        </p:spPr>
+        <p:txBody>
+          <a:bodyPr wrap="square">
+            <a:spAutoFit/>
+          </a:bodyPr>
+          <a:lstStyle/>
+          <a:p>
             <a:pPr>
               <a:spcAft>
-                <a:spcPts val="800"/>
+                <a:spcPts val="700"/>
               </a:spcAft>
-              <a:defRPr sz="1900">
+              <a:defRPr sz="1800">
                 <a:solidFill>
                   <a:srgbClr val="E6EADA"/>
                 </a:solidFill>
               </a:defRPr>
             </a:pPr>
             <a:r>
-              <a:t>Readiness score based on grade, interests, goals, deadlines, saved items and course progress.</a:t>
+              <a:t>Personal registration and student cabinet with saved opportunities, learning progress and deadlines.</a:t>
             </a:r>
           </a:p>
           <a:p>
             <a:pPr>
               <a:spcAft>
-                <a:spcPts val="800"/>
+                <a:spcPts val="700"/>
               </a:spcAft>
-              <a:defRPr sz="1900">
+              <a:defRPr sz="1800">
                 <a:solidFill>
                   <a:srgbClr val="E6EADA"/>
                 </a:solidFill>
               </a:defRPr>
             </a:pPr>
             <a:r>
-              <a:t>Strengths, risks and concrete next actions for each student.</a:t>
+              <a:t>Opportunity catalog with search, filters and match score based on profile tags.</a:t>
             </a:r>
           </a:p>
           <a:p>
             <a:pPr>
               <a:spcAft>
-                <a:spcPts val="800"/>
+                <a:spcPts val="700"/>
               </a:spcAft>
-              <a:defRPr sz="1900">
+              <a:defRPr sz="1800">
                 <a:solidFill>
                   <a:srgbClr val="E6EADA"/>
                 </a:solidFill>
               </a:defRPr>
             </a:pPr>
             <a:r>
-              <a:t>Weekly action plan for applications and learning.</a:t>
+              <a:t>Async courses with lessons, video placeholders, mini tasks and progress tracking.</a:t>
             </a:r>
           </a:p>
           <a:p>
             <a:pPr>
               <a:spcAft>
-                <a:spcPts val="800"/>
+                <a:spcPts val="700"/>
               </a:spcAft>
-              <a:defRPr sz="1900">
+              <a:defRPr sz="1800">
                 <a:solidFill>
                   <a:srgbClr val="E6EADA"/>
                 </a:solidFill>
               </a:defRPr>
             </a:pPr>
             <a:r>
-              <a:t>CV Review: upload/paste CV, find gaps, get improvements and rewrite weak bullets.</a:t>
+              <a:t>AI Analysis that produces readiness score, risks, strengths and a weekly action plan.</a:t>
+            </a:r>
+          </a:p>
+          <a:p>
+            <a:pPr>
+              <a:spcAft>
+                <a:spcPts val="700"/>
+              </a:spcAft>
+              <a:defRPr sz="1800">
+                <a:solidFill>
+                  <a:srgbClr val="E6EADA"/>
+                </a:solidFill>
+              </a:defRPr>
+            </a:pPr>
+            <a:r>
+              <a:t>Admin panel for publishing opportunities and courses through the backend API.</a:t>
             </a:r>
           </a:p>
         </p:txBody>
@@ -4361,8 +4906,8 @@
         </p:nvSpPr>
         <p:spPr>
           <a:xfrm>
-            <a:off x="9738360" y="411480"/>
-            <a:ext cx="1325880" cy="384048"/>
+            <a:off x="9464040" y="384048"/>
+            <a:ext cx="1920240" cy="438912"/>
           </a:xfrm>
           <a:prstGeom prst="rect">
             <a:avLst/>
@@ -4394,12 +4939,12 @@
           <a:p>
             <a:pPr algn="ctr"/>
             <a:r>
-              <a:rPr sz="1600" b="1">
+              <a:rPr sz="1300" b="1">
                 <a:solidFill>
                   <a:srgbClr val="0A0C0B"/>
                 </a:solidFill>
               </a:rPr>
-              <a:t>05</a:t>
+              <a:t>05 / Journey</a:t>
             </a:r>
           </a:p>
         </p:txBody>
@@ -4412,8 +4957,8 @@
         </p:nvSpPr>
         <p:spPr>
           <a:xfrm>
-            <a:off x="658368" y="566928"/>
-            <a:ext cx="8869680" cy="502920"/>
+            <a:off x="685800" y="6446520"/>
+            <a:ext cx="10698480" cy="228600"/>
           </a:xfrm>
           <a:prstGeom prst="rect">
             <a:avLst/>
@@ -4427,12 +4972,12 @@
           <a:lstStyle/>
           <a:p>
             <a:r>
-              <a:rPr sz="1400" b="1">
-                <a:solidFill>
-                  <a:srgbClr val="DFFF55"/>
+              <a:rPr sz="850">
+                <a:solidFill>
+                  <a:srgbClr val="738472"/>
                 </a:solidFill>
               </a:rPr>
-              <a:t>MENTORIA COMPASS</a:t>
+              <a:t>https://mentoria-compass.vercel.app  |  https://github.com/askarshabdanov1-collab/Mentoria</a:t>
             </a:r>
           </a:p>
         </p:txBody>
@@ -4445,8 +4990,8 @@
         </p:nvSpPr>
         <p:spPr>
           <a:xfrm>
-            <a:off x="640080" y="932688"/>
-            <a:ext cx="10058400" cy="749808"/>
+            <a:off x="658368" y="530352"/>
+            <a:ext cx="8686800" cy="402336"/>
           </a:xfrm>
           <a:prstGeom prst="rect">
             <a:avLst/>
@@ -4454,18 +4999,18 @@
           <a:noFill/>
         </p:spPr>
         <p:txBody>
-          <a:bodyPr wrap="none">
+          <a:bodyPr wrap="square">
             <a:spAutoFit/>
           </a:bodyPr>
           <a:lstStyle/>
           <a:p>
             <a:r>
-              <a:rPr sz="4200" b="1">
-                <a:solidFill>
-                  <a:srgbClr val="FFFEF0"/>
+              <a:rPr sz="1300" b="1">
+                <a:solidFill>
+                  <a:srgbClr val="DFFF55"/>
                 </a:solidFill>
               </a:rPr>
-              <a:t>User Journey</a:t>
+              <a:t>MENTORIA COMPASS / TEAM MOGGER</a:t>
             </a:r>
           </a:p>
         </p:txBody>
@@ -4478,8 +5023,8 @@
         </p:nvSpPr>
         <p:spPr>
           <a:xfrm>
-            <a:off x="667512" y="1664208"/>
-            <a:ext cx="10241280" cy="411480"/>
+            <a:off x="640080" y="896112"/>
+            <a:ext cx="10195560" cy="749808"/>
           </a:xfrm>
           <a:prstGeom prst="rect">
             <a:avLst/>
@@ -4487,18 +5032,18 @@
           <a:noFill/>
         </p:spPr>
         <p:txBody>
-          <a:bodyPr wrap="none">
+          <a:bodyPr wrap="square">
             <a:spAutoFit/>
           </a:bodyPr>
           <a:lstStyle/>
           <a:p>
             <a:r>
-              <a:rPr sz="1800" b="0">
-                <a:solidFill>
-                  <a:srgbClr val="AAB8A9"/>
+              <a:rPr sz="3800" b="1">
+                <a:solidFill>
+                  <a:srgbClr val="FFFEF0"/>
                 </a:solidFill>
               </a:rPr>
-              <a:t>Designed for a 4-minute live demo</a:t>
+              <a:t>Main User Journey</a:t>
             </a:r>
           </a:p>
         </p:txBody>
@@ -4511,8 +5056,8 @@
         </p:nvSpPr>
         <p:spPr>
           <a:xfrm>
-            <a:off x="685800" y="2148840"/>
-            <a:ext cx="10424160" cy="3931920"/>
+            <a:off x="667512" y="1627632"/>
+            <a:ext cx="10241280" cy="411480"/>
           </a:xfrm>
           <a:prstGeom prst="rect">
             <a:avLst/>
@@ -4520,83 +5065,131 @@
           <a:noFill/>
         </p:spPr>
         <p:txBody>
-          <a:bodyPr wrap="none">
+          <a:bodyPr wrap="square">
             <a:spAutoFit/>
           </a:bodyPr>
           <a:lstStyle/>
           <a:p>
+            <a:r>
+              <a:rPr sz="1700" b="0">
+                <a:solidFill>
+                  <a:srgbClr val="AAB8A9"/>
+                </a:solidFill>
+              </a:rPr>
+              <a:t>Designed to be shown clearly in a 4-minute demo</a:t>
+            </a:r>
+          </a:p>
+        </p:txBody>
+      </p:sp>
+      <p:sp>
+        <p:nvSpPr>
+          <p:cNvPr id="8" name="TextBox 7"/>
+          <p:cNvSpPr txBox="1"/>
+          <p:nvPr/>
+        </p:nvSpPr>
+        <p:spPr>
+          <a:xfrm>
+            <a:off x="685800" y="2148840"/>
+            <a:ext cx="10469880" cy="4224528"/>
+          </a:xfrm>
+          <a:prstGeom prst="rect">
+            <a:avLst/>
+          </a:prstGeom>
+          <a:noFill/>
+        </p:spPr>
+        <p:txBody>
+          <a:bodyPr wrap="square">
+            <a:spAutoFit/>
+          </a:bodyPr>
+          <a:lstStyle/>
+          <a:p>
             <a:pPr>
               <a:spcAft>
-                <a:spcPts val="800"/>
+                <a:spcPts val="700"/>
               </a:spcAft>
-              <a:defRPr sz="1900">
+              <a:defRPr sz="1700">
                 <a:solidFill>
                   <a:srgbClr val="E6EADA"/>
                 </a:solidFill>
               </a:defRPr>
             </a:pPr>
             <a:r>
-              <a:t>Student registers, selects interests and goals.</a:t>
+              <a:t>Student logs in or registers and fills profile: grade, country, school, English level, interests and goals.</a:t>
             </a:r>
           </a:p>
           <a:p>
             <a:pPr>
               <a:spcAft>
-                <a:spcPts val="800"/>
+                <a:spcPts val="700"/>
               </a:spcAft>
-              <a:defRPr sz="1900">
+              <a:defRPr sz="1700">
                 <a:solidFill>
                   <a:srgbClr val="E6EADA"/>
                 </a:solidFill>
               </a:defRPr>
             </a:pPr>
             <a:r>
-              <a:t>Compass recommends opportunities and courses with match scores.</a:t>
+              <a:t>Compass dashboard recommends opportunities and courses with profile match scores.</a:t>
             </a:r>
           </a:p>
           <a:p>
             <a:pPr>
               <a:spcAft>
-                <a:spcPts val="800"/>
+                <a:spcPts val="700"/>
               </a:spcAft>
-              <a:defRPr sz="1900">
+              <a:defRPr sz="1700">
                 <a:solidFill>
                   <a:srgbClr val="E6EADA"/>
                 </a:solidFill>
               </a:defRPr>
             </a:pPr>
             <a:r>
-              <a:t>Student saves a program, completes a lesson and opens the cabinet.</a:t>
+              <a:t>Student saves an opportunity, sees deadline pressure and starts a relevant course.</a:t>
             </a:r>
           </a:p>
           <a:p>
             <a:pPr>
               <a:spcAft>
-                <a:spcPts val="800"/>
+                <a:spcPts val="700"/>
               </a:spcAft>
-              <a:defRPr sz="1900">
+              <a:defRPr sz="1700">
                 <a:solidFill>
                   <a:srgbClr val="E6EADA"/>
                 </a:solidFill>
               </a:defRPr>
             </a:pPr>
             <a:r>
-              <a:t>Student uploads CV and receives gaps plus improvement plan.</a:t>
+              <a:t>Student completes a lesson and the personal cabinet updates progress automatically.</a:t>
             </a:r>
           </a:p>
           <a:p>
             <a:pPr>
               <a:spcAft>
-                <a:spcPts val="800"/>
+                <a:spcPts val="700"/>
               </a:spcAft>
-              <a:defRPr sz="1900">
+              <a:defRPr sz="1700">
                 <a:solidFill>
                   <a:srgbClr val="E6EADA"/>
                 </a:solidFill>
               </a:defRPr>
             </a:pPr>
             <a:r>
-              <a:t>Admin logs in and publishes a new opportunity through the backend.</a:t>
+              <a:t>Student opens AI Analysis and gets next actions for applications and learning.</a:t>
+            </a:r>
+          </a:p>
+          <a:p>
+            <a:pPr>
+              <a:spcAft>
+                <a:spcPts val="700"/>
+              </a:spcAft>
+              <a:defRPr sz="1700">
+                <a:solidFill>
+                  <a:srgbClr val="E6EADA"/>
+                </a:solidFill>
+              </a:defRPr>
+            </a:pPr>
+            <a:r>
+              <a:t>Admin logs in and adds a new opportunity, which appears immediately in the catalog.</a:t>
             </a:r>
           </a:p>
         </p:txBody>
@@ -4678,8 +5271,8 @@
         </p:nvSpPr>
         <p:spPr>
           <a:xfrm>
-            <a:off x="9738360" y="411480"/>
-            <a:ext cx="1325880" cy="384048"/>
+            <a:off x="9464040" y="384048"/>
+            <a:ext cx="1920240" cy="438912"/>
           </a:xfrm>
           <a:prstGeom prst="rect">
             <a:avLst/>
@@ -4711,12 +5304,12 @@
           <a:p>
             <a:pPr algn="ctr"/>
             <a:r>
-              <a:rPr sz="1600" b="1">
+              <a:rPr sz="1300" b="1">
                 <a:solidFill>
                   <a:srgbClr val="0A0C0B"/>
                 </a:solidFill>
               </a:rPr>
-              <a:t>06</a:t>
+              <a:t>06 / AI</a:t>
             </a:r>
           </a:p>
         </p:txBody>
@@ -4729,8 +5322,8 @@
         </p:nvSpPr>
         <p:spPr>
           <a:xfrm>
-            <a:off x="658368" y="566928"/>
-            <a:ext cx="8869680" cy="502920"/>
+            <a:off x="685800" y="6446520"/>
+            <a:ext cx="10698480" cy="228600"/>
           </a:xfrm>
           <a:prstGeom prst="rect">
             <a:avLst/>
@@ -4744,12 +5337,12 @@
           <a:lstStyle/>
           <a:p>
             <a:r>
-              <a:rPr sz="1400" b="1">
-                <a:solidFill>
-                  <a:srgbClr val="DFFF55"/>
+              <a:rPr sz="850">
+                <a:solidFill>
+                  <a:srgbClr val="738472"/>
                 </a:solidFill>
               </a:rPr>
-              <a:t>MENTORIA COMPASS</a:t>
+              <a:t>https://mentoria-compass.vercel.app  |  https://github.com/askarshabdanov1-collab/Mentoria</a:t>
             </a:r>
           </a:p>
         </p:txBody>
@@ -4762,8 +5355,8 @@
         </p:nvSpPr>
         <p:spPr>
           <a:xfrm>
-            <a:off x="640080" y="932688"/>
-            <a:ext cx="10058400" cy="749808"/>
+            <a:off x="658368" y="530352"/>
+            <a:ext cx="8686800" cy="402336"/>
           </a:xfrm>
           <a:prstGeom prst="rect">
             <a:avLst/>
@@ -4771,18 +5364,18 @@
           <a:noFill/>
         </p:spPr>
         <p:txBody>
-          <a:bodyPr wrap="none">
+          <a:bodyPr wrap="square">
             <a:spAutoFit/>
           </a:bodyPr>
           <a:lstStyle/>
           <a:p>
             <a:r>
-              <a:rPr sz="4200" b="1">
-                <a:solidFill>
-                  <a:srgbClr val="FFFEF0"/>
+              <a:rPr sz="1300" b="1">
+                <a:solidFill>
+                  <a:srgbClr val="DFFF55"/>
                 </a:solidFill>
               </a:rPr>
-              <a:t>Technical Architecture</a:t>
+              <a:t>MENTORIA COMPASS / TEAM MOGGER</a:t>
             </a:r>
           </a:p>
         </p:txBody>
@@ -4795,8 +5388,8 @@
         </p:nvSpPr>
         <p:spPr>
           <a:xfrm>
-            <a:off x="667512" y="1664208"/>
-            <a:ext cx="10241280" cy="411480"/>
+            <a:off x="640080" y="896112"/>
+            <a:ext cx="10195560" cy="749808"/>
           </a:xfrm>
           <a:prstGeom prst="rect">
             <a:avLst/>
@@ -4804,18 +5397,18 @@
           <a:noFill/>
         </p:spPr>
         <p:txBody>
-          <a:bodyPr wrap="none">
+          <a:bodyPr wrap="square">
             <a:spAutoFit/>
           </a:bodyPr>
           <a:lstStyle/>
           <a:p>
             <a:r>
-              <a:rPr sz="1800" b="0">
-                <a:solidFill>
-                  <a:srgbClr val="AAB8A9"/>
+              <a:rPr sz="3800" b="1">
+                <a:solidFill>
+                  <a:srgbClr val="FFFEF0"/>
                 </a:solidFill>
               </a:rPr>
-              <a:t>Full-stack product deployed on Vercel</a:t>
+              <a:t>AI Roadmap and Recommendations</a:t>
             </a:r>
           </a:p>
         </p:txBody>
@@ -4828,8 +5421,8 @@
         </p:nvSpPr>
         <p:spPr>
           <a:xfrm>
-            <a:off x="685800" y="2148840"/>
-            <a:ext cx="10424160" cy="3931920"/>
+            <a:off x="667512" y="1627632"/>
+            <a:ext cx="10241280" cy="411480"/>
           </a:xfrm>
           <a:prstGeom prst="rect">
             <a:avLst/>
@@ -4837,83 +5430,116 @@
           <a:noFill/>
         </p:spPr>
         <p:txBody>
-          <a:bodyPr wrap="none">
+          <a:bodyPr wrap="square">
             <a:spAutoFit/>
           </a:bodyPr>
           <a:lstStyle/>
           <a:p>
+            <a:r>
+              <a:rPr sz="1700" b="0">
+                <a:solidFill>
+                  <a:srgbClr val="AAB8A9"/>
+                </a:solidFill>
+              </a:rPr>
+              <a:t>Practical analysis that works instantly without external API keys</a:t>
+            </a:r>
+          </a:p>
+        </p:txBody>
+      </p:sp>
+      <p:sp>
+        <p:nvSpPr>
+          <p:cNvPr id="8" name="TextBox 7"/>
+          <p:cNvSpPr txBox="1"/>
+          <p:nvPr/>
+        </p:nvSpPr>
+        <p:spPr>
+          <a:xfrm>
+            <a:off x="685800" y="2148840"/>
+            <a:ext cx="10469880" cy="4224528"/>
+          </a:xfrm>
+          <a:prstGeom prst="rect">
+            <a:avLst/>
+          </a:prstGeom>
+          <a:noFill/>
+        </p:spPr>
+        <p:txBody>
+          <a:bodyPr wrap="square">
+            <a:spAutoFit/>
+          </a:bodyPr>
+          <a:lstStyle/>
+          <a:p>
             <a:pPr>
               <a:spcAft>
-                <a:spcPts val="800"/>
+                <a:spcPts val="700"/>
               </a:spcAft>
-              <a:defRPr sz="1900">
+              <a:defRPr sz="1800">
                 <a:solidFill>
                   <a:srgbClr val="E6EADA"/>
                 </a:solidFill>
               </a:defRPr>
             </a:pPr>
             <a:r>
-              <a:t>Frontend: React + Vite + responsive dashboard UI.</a:t>
+              <a:t>Readiness score is calculated from profile completeness, saved opportunities, course progress and deadline urgency.</a:t>
             </a:r>
           </a:p>
           <a:p>
             <a:pPr>
               <a:spcAft>
-                <a:spcPts val="800"/>
+                <a:spcPts val="700"/>
               </a:spcAft>
-              <a:defRPr sz="1900">
+              <a:defRPr sz="1800">
                 <a:solidFill>
                   <a:srgbClr val="E6EADA"/>
                 </a:solidFill>
               </a:defRPr>
             </a:pPr>
             <a:r>
-              <a:t>Backend: Node serverless API on Vercel.</a:t>
+              <a:t>The system detects risks: missing saved opportunities, low progress, close deadlines and weak portfolio focus.</a:t>
             </a:r>
           </a:p>
           <a:p>
             <a:pPr>
               <a:spcAft>
-                <a:spcPts val="800"/>
+                <a:spcPts val="700"/>
               </a:spcAft>
-              <a:defRPr sz="1900">
+              <a:defRPr sz="1800">
                 <a:solidFill>
                   <a:srgbClr val="E6EADA"/>
                 </a:solidFill>
               </a:defRPr>
             </a:pPr>
             <a:r>
-              <a:t>Auth: registration, login, logout and bearer token sessions.</a:t>
+              <a:t>Students receive concrete next actions, not generic advice.</a:t>
             </a:r>
           </a:p>
           <a:p>
             <a:pPr>
               <a:spcAft>
-                <a:spcPts val="800"/>
+                <a:spcPts val="700"/>
               </a:spcAft>
-              <a:defRPr sz="1900">
+              <a:defRPr sz="1800">
                 <a:solidFill>
                   <a:srgbClr val="E6EADA"/>
                 </a:solidFill>
               </a:defRPr>
             </a:pPr>
             <a:r>
-              <a:t>Data: users, progress, saved opportunities, CV reviews, courses and admin content.</a:t>
+              <a:t>Weekly plan turns recommendations into daily tasks: choose opportunity, finish lesson, draft answer, ask mentor, submit.</a:t>
             </a:r>
           </a:p>
           <a:p>
             <a:pPr>
               <a:spcAft>
-                <a:spcPts val="800"/>
+                <a:spcPts val="700"/>
               </a:spcAft>
-              <a:defRPr sz="1900">
+              <a:defRPr sz="1800">
                 <a:solidFill>
                   <a:srgbClr val="E6EADA"/>
                 </a:solidFill>
               </a:defRPr>
             </a:pPr>
             <a:r>
-              <a:t>Production URL and GitHub repository are connected.</a:t>
+              <a:t>This helps Mentoria increase retention because students always know the next step.</a:t>
             </a:r>
           </a:p>
         </p:txBody>
@@ -4995,8 +5621,8 @@
         </p:nvSpPr>
         <p:spPr>
           <a:xfrm>
-            <a:off x="9738360" y="411480"/>
-            <a:ext cx="1325880" cy="384048"/>
+            <a:off x="9464040" y="384048"/>
+            <a:ext cx="1920240" cy="438912"/>
           </a:xfrm>
           <a:prstGeom prst="rect">
             <a:avLst/>
@@ -5028,12 +5654,12 @@
           <a:p>
             <a:pPr algn="ctr"/>
             <a:r>
-              <a:rPr sz="1600" b="1">
+              <a:rPr sz="1300" b="1">
                 <a:solidFill>
                   <a:srgbClr val="0A0C0B"/>
                 </a:solidFill>
               </a:rPr>
-              <a:t>07</a:t>
+              <a:t>07 / CV Review</a:t>
             </a:r>
           </a:p>
         </p:txBody>
@@ -5046,8 +5672,8 @@
         </p:nvSpPr>
         <p:spPr>
           <a:xfrm>
-            <a:off x="658368" y="566928"/>
-            <a:ext cx="8869680" cy="502920"/>
+            <a:off x="685800" y="6446520"/>
+            <a:ext cx="10698480" cy="228600"/>
           </a:xfrm>
           <a:prstGeom prst="rect">
             <a:avLst/>
@@ -5061,12 +5687,12 @@
           <a:lstStyle/>
           <a:p>
             <a:r>
-              <a:rPr sz="1400" b="1">
-                <a:solidFill>
-                  <a:srgbClr val="DFFF55"/>
+              <a:rPr sz="850">
+                <a:solidFill>
+                  <a:srgbClr val="738472"/>
                 </a:solidFill>
               </a:rPr>
-              <a:t>MENTORIA COMPASS</a:t>
+              <a:t>https://mentoria-compass.vercel.app  |  https://github.com/askarshabdanov1-collab/Mentoria</a:t>
             </a:r>
           </a:p>
         </p:txBody>
@@ -5079,8 +5705,325 @@
         </p:nvSpPr>
         <p:spPr>
           <a:xfrm>
-            <a:off x="640080" y="932688"/>
-            <a:ext cx="10058400" cy="749808"/>
+            <a:off x="658368" y="530352"/>
+            <a:ext cx="8686800" cy="402336"/>
+          </a:xfrm>
+          <a:prstGeom prst="rect">
+            <a:avLst/>
+          </a:prstGeom>
+          <a:noFill/>
+        </p:spPr>
+        <p:txBody>
+          <a:bodyPr wrap="square">
+            <a:spAutoFit/>
+          </a:bodyPr>
+          <a:lstStyle/>
+          <a:p>
+            <a:r>
+              <a:rPr sz="1300" b="1">
+                <a:solidFill>
+                  <a:srgbClr val="DFFF55"/>
+                </a:solidFill>
+              </a:rPr>
+              <a:t>MENTORIA COMPASS / TEAM MOGGER</a:t>
+            </a:r>
+          </a:p>
+        </p:txBody>
+      </p:sp>
+      <p:sp>
+        <p:nvSpPr>
+          <p:cNvPr id="6" name="TextBox 5"/>
+          <p:cNvSpPr txBox="1"/>
+          <p:nvPr/>
+        </p:nvSpPr>
+        <p:spPr>
+          <a:xfrm>
+            <a:off x="640080" y="896112"/>
+            <a:ext cx="10195560" cy="749808"/>
+          </a:xfrm>
+          <a:prstGeom prst="rect">
+            <a:avLst/>
+          </a:prstGeom>
+          <a:noFill/>
+        </p:spPr>
+        <p:txBody>
+          <a:bodyPr wrap="square">
+            <a:spAutoFit/>
+          </a:bodyPr>
+          <a:lstStyle/>
+          <a:p>
+            <a:r>
+              <a:rPr sz="3800" b="1">
+                <a:solidFill>
+                  <a:srgbClr val="FFFEF0"/>
+                </a:solidFill>
+              </a:rPr>
+              <a:t>CV Review: Find Gaps and Improve</a:t>
+            </a:r>
+          </a:p>
+        </p:txBody>
+      </p:sp>
+      <p:sp>
+        <p:nvSpPr>
+          <p:cNvPr id="7" name="TextBox 6"/>
+          <p:cNvSpPr txBox="1"/>
+          <p:nvPr/>
+        </p:nvSpPr>
+        <p:spPr>
+          <a:xfrm>
+            <a:off x="667512" y="1627632"/>
+            <a:ext cx="10241280" cy="411480"/>
+          </a:xfrm>
+          <a:prstGeom prst="rect">
+            <a:avLst/>
+          </a:prstGeom>
+          <a:noFill/>
+        </p:spPr>
+        <p:txBody>
+          <a:bodyPr wrap="square">
+            <a:spAutoFit/>
+          </a:bodyPr>
+          <a:lstStyle/>
+          <a:p>
+            <a:r>
+              <a:rPr sz="1700" b="0">
+                <a:solidFill>
+                  <a:srgbClr val="AAB8A9"/>
+                </a:solidFill>
+              </a:rPr>
+              <a:t>Students can upload or paste a CV and receive application-focused feedback</a:t>
+            </a:r>
+          </a:p>
+        </p:txBody>
+      </p:sp>
+      <p:sp>
+        <p:nvSpPr>
+          <p:cNvPr id="8" name="TextBox 7"/>
+          <p:cNvSpPr txBox="1"/>
+          <p:nvPr/>
+        </p:nvSpPr>
+        <p:spPr>
+          <a:xfrm>
+            <a:off x="685800" y="2148840"/>
+            <a:ext cx="10469880" cy="4224528"/>
+          </a:xfrm>
+          <a:prstGeom prst="rect">
+            <a:avLst/>
+          </a:prstGeom>
+          <a:noFill/>
+        </p:spPr>
+        <p:txBody>
+          <a:bodyPr wrap="square">
+            <a:spAutoFit/>
+          </a:bodyPr>
+          <a:lstStyle/>
+          <a:p>
+            <a:pPr>
+              <a:spcAft>
+                <a:spcPts val="700"/>
+              </a:spcAft>
+              <a:defRPr sz="1800">
+                <a:solidFill>
+                  <a:srgbClr val="E6EADA"/>
+                </a:solidFill>
+              </a:defRPr>
+            </a:pPr>
+            <a:r>
+              <a:t>The platform checks whether the CV has contact details, education, projects, skills, awards and links.</a:t>
+            </a:r>
+          </a:p>
+          <a:p>
+            <a:pPr>
+              <a:spcAft>
+                <a:spcPts val="700"/>
+              </a:spcAft>
+              <a:defRPr sz="1800">
+                <a:solidFill>
+                  <a:srgbClr val="E6EADA"/>
+                </a:solidFill>
+              </a:defRPr>
+            </a:pPr>
+            <a:r>
+              <a:t>It detects weak evidence: no numbers, passive bullets, missing portfolio links and unclear achievements.</a:t>
+            </a:r>
+          </a:p>
+          <a:p>
+            <a:pPr>
+              <a:spcAft>
+                <a:spcPts val="700"/>
+              </a:spcAft>
+              <a:defRPr sz="1800">
+                <a:solidFill>
+                  <a:srgbClr val="E6EADA"/>
+                </a:solidFill>
+              </a:defRPr>
+            </a:pPr>
+            <a:r>
+              <a:t>Students get a CV readiness score and prioritized gaps to fix first.</a:t>
+            </a:r>
+          </a:p>
+          <a:p>
+            <a:pPr>
+              <a:spcAft>
+                <a:spcPts val="700"/>
+              </a:spcAft>
+              <a:defRPr sz="1800">
+                <a:solidFill>
+                  <a:srgbClr val="E6EADA"/>
+                </a:solidFill>
+              </a:defRPr>
+            </a:pPr>
+            <a:r>
+              <a:t>The tool suggests concrete improvements: stronger summary, quantified impact, project section and rewritten bullets.</a:t>
+            </a:r>
+          </a:p>
+          <a:p>
+            <a:pPr>
+              <a:spcAft>
+                <a:spcPts val="700"/>
+              </a:spcAft>
+              <a:defRPr sz="1800">
+                <a:solidFill>
+                  <a:srgbClr val="E6EADA"/>
+                </a:solidFill>
+              </a:defRPr>
+            </a:pPr>
+            <a:r>
+              <a:t>CV reviews are saved in the student account so progress can be revisited later.</a:t>
+            </a:r>
+          </a:p>
+        </p:txBody>
+      </p:sp>
+    </p:spTree>
+  </p:cSld>
+  <p:clrMapOvr>
+    <a:masterClrMapping/>
+  </p:clrMapOvr>
+</p:sld>
+</file>
+
+<file path=ppt/slides/slide8.xml><?xml version="1.0" encoding="utf-8"?>
+<p:sld xmlns:a="http://schemas.openxmlformats.org/drawingml/2006/main" xmlns:p="http://schemas.openxmlformats.org/presentationml/2006/main" xmlns:r="http://schemas.openxmlformats.org/officeDocument/2006/relationships">
+  <p:cSld>
+    <p:bg>
+      <p:bgPr>
+        <a:solidFill>
+          <a:srgbClr val="0A0C0B"/>
+        </a:solidFill>
+        <a:effectLst/>
+      </p:bgPr>
+    </p:bg>
+    <p:spTree>
+      <p:nvGrpSpPr>
+        <p:cNvPr id="1" name=""/>
+        <p:cNvGrpSpPr/>
+        <p:nvPr/>
+      </p:nvGrpSpPr>
+      <p:grpSpPr/>
+      <p:sp>
+        <p:nvSpPr>
+          <p:cNvPr id="2" name="Rectangle 1"/>
+          <p:cNvSpPr/>
+          <p:nvPr/>
+        </p:nvSpPr>
+        <p:spPr>
+          <a:xfrm>
+            <a:off x="0" y="0"/>
+            <a:ext cx="12191695" cy="109728"/>
+          </a:xfrm>
+          <a:prstGeom prst="rect">
+            <a:avLst/>
+          </a:prstGeom>
+          <a:solidFill>
+            <a:srgbClr val="DFFF55"/>
+          </a:solidFill>
+          <a:ln>
+            <a:noFill/>
+          </a:ln>
+        </p:spPr>
+        <p:style>
+          <a:lnRef idx="1">
+            <a:schemeClr val="accent1"/>
+          </a:lnRef>
+          <a:fillRef idx="3">
+            <a:schemeClr val="accent1"/>
+          </a:fillRef>
+          <a:effectRef idx="2">
+            <a:schemeClr val="accent1"/>
+          </a:effectRef>
+          <a:fontRef idx="minor">
+            <a:schemeClr val="lt1"/>
+          </a:fontRef>
+        </p:style>
+        <p:txBody>
+          <a:bodyPr rtlCol="0" anchor="ctr"/>
+          <a:lstStyle/>
+          <a:p>
+            <a:pPr algn="ctr"/>
+          </a:p>
+        </p:txBody>
+      </p:sp>
+      <p:sp>
+        <p:nvSpPr>
+          <p:cNvPr id="3" name="Rectangle 2"/>
+          <p:cNvSpPr/>
+          <p:nvPr/>
+        </p:nvSpPr>
+        <p:spPr>
+          <a:xfrm>
+            <a:off x="9464040" y="384048"/>
+            <a:ext cx="1920240" cy="438912"/>
+          </a:xfrm>
+          <a:prstGeom prst="rect">
+            <a:avLst/>
+          </a:prstGeom>
+          <a:solidFill>
+            <a:srgbClr val="5AD7FF"/>
+          </a:solidFill>
+          <a:ln>
+            <a:noFill/>
+          </a:ln>
+        </p:spPr>
+        <p:style>
+          <a:lnRef idx="1">
+            <a:schemeClr val="accent1"/>
+          </a:lnRef>
+          <a:fillRef idx="3">
+            <a:schemeClr val="accent1"/>
+          </a:fillRef>
+          <a:effectRef idx="2">
+            <a:schemeClr val="accent1"/>
+          </a:effectRef>
+          <a:fontRef idx="minor">
+            <a:schemeClr val="lt1"/>
+          </a:fontRef>
+        </p:style>
+        <p:txBody>
+          <a:bodyPr rtlCol="0" anchor="ctr"/>
+          <a:lstStyle/>
+          <a:p>
+            <a:pPr algn="ctr"/>
+            <a:r>
+              <a:rPr sz="1300" b="1">
+                <a:solidFill>
+                  <a:srgbClr val="0A0C0B"/>
+                </a:solidFill>
+              </a:rPr>
+              <a:t>08 / Technology</a:t>
+            </a:r>
+          </a:p>
+        </p:txBody>
+      </p:sp>
+      <p:sp>
+        <p:nvSpPr>
+          <p:cNvPr id="4" name="TextBox 3"/>
+          <p:cNvSpPr txBox="1"/>
+          <p:nvPr/>
+        </p:nvSpPr>
+        <p:spPr>
+          <a:xfrm>
+            <a:off x="685800" y="6446520"/>
+            <a:ext cx="10698480" cy="228600"/>
           </a:xfrm>
           <a:prstGeom prst="rect">
             <a:avLst/>
@@ -5094,12 +6037,45 @@
           <a:lstStyle/>
           <a:p>
             <a:r>
-              <a:rPr sz="4200" b="1">
-                <a:solidFill>
-                  <a:srgbClr val="FFFEF0"/>
+              <a:rPr sz="850">
+                <a:solidFill>
+                  <a:srgbClr val="738472"/>
                 </a:solidFill>
               </a:rPr>
-              <a:t>Impact for Mentoria</a:t>
+              <a:t>https://mentoria-compass.vercel.app  |  https://github.com/askarshabdanov1-collab/Mentoria</a:t>
+            </a:r>
+          </a:p>
+        </p:txBody>
+      </p:sp>
+      <p:sp>
+        <p:nvSpPr>
+          <p:cNvPr id="5" name="TextBox 4"/>
+          <p:cNvSpPr txBox="1"/>
+          <p:nvPr/>
+        </p:nvSpPr>
+        <p:spPr>
+          <a:xfrm>
+            <a:off x="658368" y="530352"/>
+            <a:ext cx="8686800" cy="402336"/>
+          </a:xfrm>
+          <a:prstGeom prst="rect">
+            <a:avLst/>
+          </a:prstGeom>
+          <a:noFill/>
+        </p:spPr>
+        <p:txBody>
+          <a:bodyPr wrap="square">
+            <a:spAutoFit/>
+          </a:bodyPr>
+          <a:lstStyle/>
+          <a:p>
+            <a:r>
+              <a:rPr sz="1300" b="1">
+                <a:solidFill>
+                  <a:srgbClr val="DFFF55"/>
+                </a:solidFill>
+              </a:rPr>
+              <a:t>MENTORIA COMPASS / TEAM MOGGER</a:t>
             </a:r>
           </a:p>
         </p:txBody>
@@ -5112,8 +6088,292 @@
         </p:nvSpPr>
         <p:spPr>
           <a:xfrm>
-            <a:off x="667512" y="1664208"/>
+            <a:off x="640080" y="896112"/>
+            <a:ext cx="10195560" cy="749808"/>
+          </a:xfrm>
+          <a:prstGeom prst="rect">
+            <a:avLst/>
+          </a:prstGeom>
+          <a:noFill/>
+        </p:spPr>
+        <p:txBody>
+          <a:bodyPr wrap="square">
+            <a:spAutoFit/>
+          </a:bodyPr>
+          <a:lstStyle/>
+          <a:p>
+            <a:r>
+              <a:rPr sz="3800" b="1">
+                <a:solidFill>
+                  <a:srgbClr val="FFFEF0"/>
+                </a:solidFill>
+              </a:rPr>
+              <a:t>Technical Architecture</a:t>
+            </a:r>
+          </a:p>
+        </p:txBody>
+      </p:sp>
+      <p:sp>
+        <p:nvSpPr>
+          <p:cNvPr id="7" name="TextBox 6"/>
+          <p:cNvSpPr txBox="1"/>
+          <p:nvPr/>
+        </p:nvSpPr>
+        <p:spPr>
+          <a:xfrm>
+            <a:off x="667512" y="1627632"/>
             <a:ext cx="10241280" cy="411480"/>
+          </a:xfrm>
+          <a:prstGeom prst="rect">
+            <a:avLst/>
+          </a:prstGeom>
+          <a:noFill/>
+        </p:spPr>
+        <p:txBody>
+          <a:bodyPr wrap="square">
+            <a:spAutoFit/>
+          </a:bodyPr>
+          <a:lstStyle/>
+          <a:p>
+            <a:r>
+              <a:rPr sz="1700" b="0">
+                <a:solidFill>
+                  <a:srgbClr val="AAB8A9"/>
+                </a:solidFill>
+              </a:rPr>
+              <a:t>Full-stack app deployed to production</a:t>
+            </a:r>
+          </a:p>
+        </p:txBody>
+      </p:sp>
+      <p:sp>
+        <p:nvSpPr>
+          <p:cNvPr id="8" name="TextBox 7"/>
+          <p:cNvSpPr txBox="1"/>
+          <p:nvPr/>
+        </p:nvSpPr>
+        <p:spPr>
+          <a:xfrm>
+            <a:off x="685800" y="2148840"/>
+            <a:ext cx="10469880" cy="4224528"/>
+          </a:xfrm>
+          <a:prstGeom prst="rect">
+            <a:avLst/>
+          </a:prstGeom>
+          <a:noFill/>
+        </p:spPr>
+        <p:txBody>
+          <a:bodyPr wrap="square">
+            <a:spAutoFit/>
+          </a:bodyPr>
+          <a:lstStyle/>
+          <a:p>
+            <a:pPr>
+              <a:spcAft>
+                <a:spcPts val="700"/>
+              </a:spcAft>
+              <a:defRPr sz="1800">
+                <a:solidFill>
+                  <a:srgbClr val="E6EADA"/>
+                </a:solidFill>
+              </a:defRPr>
+            </a:pPr>
+            <a:r>
+              <a:t>Frontend: React + Vite dashboard with responsive navigation and product-style UI.</a:t>
+            </a:r>
+          </a:p>
+          <a:p>
+            <a:pPr>
+              <a:spcAft>
+                <a:spcPts val="700"/>
+              </a:spcAft>
+              <a:defRPr sz="1800">
+                <a:solidFill>
+                  <a:srgbClr val="E6EADA"/>
+                </a:solidFill>
+              </a:defRPr>
+            </a:pPr>
+            <a:r>
+              <a:t>Backend: Node API with auth, user profile, progress, saved items, admin content and CV analysis routes.</a:t>
+            </a:r>
+          </a:p>
+          <a:p>
+            <a:pPr>
+              <a:spcAft>
+                <a:spcPts val="700"/>
+              </a:spcAft>
+              <a:defRPr sz="1800">
+                <a:solidFill>
+                  <a:srgbClr val="E6EADA"/>
+                </a:solidFill>
+              </a:defRPr>
+            </a:pPr>
+            <a:r>
+              <a:t>Authentication: registration, login, logout and bearer-token sessions.</a:t>
+            </a:r>
+          </a:p>
+          <a:p>
+            <a:pPr>
+              <a:spcAft>
+                <a:spcPts val="700"/>
+              </a:spcAft>
+              <a:defRPr sz="1800">
+                <a:solidFill>
+                  <a:srgbClr val="E6EADA"/>
+                </a:solidFill>
+              </a:defRPr>
+            </a:pPr>
+            <a:r>
+              <a:t>Deployment: Vercel production app connected to GitHub repository.</a:t>
+            </a:r>
+          </a:p>
+          <a:p>
+            <a:pPr>
+              <a:spcAft>
+                <a:spcPts val="700"/>
+              </a:spcAft>
+              <a:defRPr sz="1800">
+                <a:solidFill>
+                  <a:srgbClr val="E6EADA"/>
+                </a:solidFill>
+              </a:defRPr>
+            </a:pPr>
+            <a:r>
+              <a:t>Current storage: JSON seed/serverless storage for hackathon delivery; next production step is Supabase/Neon Postgres.</a:t>
+            </a:r>
+          </a:p>
+        </p:txBody>
+      </p:sp>
+    </p:spTree>
+  </p:cSld>
+  <p:clrMapOvr>
+    <a:masterClrMapping/>
+  </p:clrMapOvr>
+</p:sld>
+</file>
+
+<file path=ppt/slides/slide9.xml><?xml version="1.0" encoding="utf-8"?>
+<p:sld xmlns:a="http://schemas.openxmlformats.org/drawingml/2006/main" xmlns:p="http://schemas.openxmlformats.org/presentationml/2006/main" xmlns:r="http://schemas.openxmlformats.org/officeDocument/2006/relationships">
+  <p:cSld>
+    <p:bg>
+      <p:bgPr>
+        <a:solidFill>
+          <a:srgbClr val="0A0C0B"/>
+        </a:solidFill>
+        <a:effectLst/>
+      </p:bgPr>
+    </p:bg>
+    <p:spTree>
+      <p:nvGrpSpPr>
+        <p:cNvPr id="1" name=""/>
+        <p:cNvGrpSpPr/>
+        <p:nvPr/>
+      </p:nvGrpSpPr>
+      <p:grpSpPr/>
+      <p:sp>
+        <p:nvSpPr>
+          <p:cNvPr id="2" name="Rectangle 1"/>
+          <p:cNvSpPr/>
+          <p:nvPr/>
+        </p:nvSpPr>
+        <p:spPr>
+          <a:xfrm>
+            <a:off x="0" y="0"/>
+            <a:ext cx="12191695" cy="109728"/>
+          </a:xfrm>
+          <a:prstGeom prst="rect">
+            <a:avLst/>
+          </a:prstGeom>
+          <a:solidFill>
+            <a:srgbClr val="DFFF55"/>
+          </a:solidFill>
+          <a:ln>
+            <a:noFill/>
+          </a:ln>
+        </p:spPr>
+        <p:style>
+          <a:lnRef idx="1">
+            <a:schemeClr val="accent1"/>
+          </a:lnRef>
+          <a:fillRef idx="3">
+            <a:schemeClr val="accent1"/>
+          </a:fillRef>
+          <a:effectRef idx="2">
+            <a:schemeClr val="accent1"/>
+          </a:effectRef>
+          <a:fontRef idx="minor">
+            <a:schemeClr val="lt1"/>
+          </a:fontRef>
+        </p:style>
+        <p:txBody>
+          <a:bodyPr rtlCol="0" anchor="ctr"/>
+          <a:lstStyle/>
+          <a:p>
+            <a:pPr algn="ctr"/>
+          </a:p>
+        </p:txBody>
+      </p:sp>
+      <p:sp>
+        <p:nvSpPr>
+          <p:cNvPr id="3" name="Rectangle 2"/>
+          <p:cNvSpPr/>
+          <p:nvPr/>
+        </p:nvSpPr>
+        <p:spPr>
+          <a:xfrm>
+            <a:off x="9464040" y="384048"/>
+            <a:ext cx="1920240" cy="438912"/>
+          </a:xfrm>
+          <a:prstGeom prst="rect">
+            <a:avLst/>
+          </a:prstGeom>
+          <a:solidFill>
+            <a:srgbClr val="5AD7FF"/>
+          </a:solidFill>
+          <a:ln>
+            <a:noFill/>
+          </a:ln>
+        </p:spPr>
+        <p:style>
+          <a:lnRef idx="1">
+            <a:schemeClr val="accent1"/>
+          </a:lnRef>
+          <a:fillRef idx="3">
+            <a:schemeClr val="accent1"/>
+          </a:fillRef>
+          <a:effectRef idx="2">
+            <a:schemeClr val="accent1"/>
+          </a:effectRef>
+          <a:fontRef idx="minor">
+            <a:schemeClr val="lt1"/>
+          </a:fontRef>
+        </p:style>
+        <p:txBody>
+          <a:bodyPr rtlCol="0" anchor="ctr"/>
+          <a:lstStyle/>
+          <a:p>
+            <a:pPr algn="ctr"/>
+            <a:r>
+              <a:rPr sz="1300" b="1">
+                <a:solidFill>
+                  <a:srgbClr val="0A0C0B"/>
+                </a:solidFill>
+              </a:rPr>
+              <a:t>09 / Impact</a:t>
+            </a:r>
+          </a:p>
+        </p:txBody>
+      </p:sp>
+      <p:sp>
+        <p:nvSpPr>
+          <p:cNvPr id="4" name="TextBox 3"/>
+          <p:cNvSpPr txBox="1"/>
+          <p:nvPr/>
+        </p:nvSpPr>
+        <p:spPr>
+          <a:xfrm>
+            <a:off x="685800" y="6446520"/>
+            <a:ext cx="10698480" cy="228600"/>
           </a:xfrm>
           <a:prstGeom prst="rect">
             <a:avLst/>
@@ -5127,12 +6387,78 @@
           <a:lstStyle/>
           <a:p>
             <a:r>
-              <a:rPr sz="1800" b="0">
-                <a:solidFill>
-                  <a:srgbClr val="AAB8A9"/>
+              <a:rPr sz="850">
+                <a:solidFill>
+                  <a:srgbClr val="738472"/>
                 </a:solidFill>
               </a:rPr>
-              <a:t>A scalable platform for students, mentors and partners</a:t>
+              <a:t>https://mentoria-compass.vercel.app  |  https://github.com/askarshabdanov1-collab/Mentoria</a:t>
+            </a:r>
+          </a:p>
+        </p:txBody>
+      </p:sp>
+      <p:sp>
+        <p:nvSpPr>
+          <p:cNvPr id="5" name="TextBox 4"/>
+          <p:cNvSpPr txBox="1"/>
+          <p:nvPr/>
+        </p:nvSpPr>
+        <p:spPr>
+          <a:xfrm>
+            <a:off x="658368" y="530352"/>
+            <a:ext cx="8686800" cy="402336"/>
+          </a:xfrm>
+          <a:prstGeom prst="rect">
+            <a:avLst/>
+          </a:prstGeom>
+          <a:noFill/>
+        </p:spPr>
+        <p:txBody>
+          <a:bodyPr wrap="square">
+            <a:spAutoFit/>
+          </a:bodyPr>
+          <a:lstStyle/>
+          <a:p>
+            <a:r>
+              <a:rPr sz="1300" b="1">
+                <a:solidFill>
+                  <a:srgbClr val="DFFF55"/>
+                </a:solidFill>
+              </a:rPr>
+              <a:t>MENTORIA COMPASS / TEAM MOGGER</a:t>
+            </a:r>
+          </a:p>
+        </p:txBody>
+      </p:sp>
+      <p:sp>
+        <p:nvSpPr>
+          <p:cNvPr id="6" name="TextBox 5"/>
+          <p:cNvSpPr txBox="1"/>
+          <p:nvPr/>
+        </p:nvSpPr>
+        <p:spPr>
+          <a:xfrm>
+            <a:off x="640080" y="896112"/>
+            <a:ext cx="10195560" cy="749808"/>
+          </a:xfrm>
+          <a:prstGeom prst="rect">
+            <a:avLst/>
+          </a:prstGeom>
+          <a:noFill/>
+        </p:spPr>
+        <p:txBody>
+          <a:bodyPr wrap="square">
+            <a:spAutoFit/>
+          </a:bodyPr>
+          <a:lstStyle/>
+          <a:p>
+            <a:r>
+              <a:rPr sz="3800" b="1">
+                <a:solidFill>
+                  <a:srgbClr val="FFFEF0"/>
+                </a:solidFill>
+              </a:rPr>
+              <a:t>Impact for Mentoria</a:t>
             </a:r>
           </a:p>
         </p:txBody>
@@ -5145,8 +6471,8 @@
         </p:nvSpPr>
         <p:spPr>
           <a:xfrm>
-            <a:off x="685800" y="2148840"/>
-            <a:ext cx="10424160" cy="3931920"/>
+            <a:off x="667512" y="1627632"/>
+            <a:ext cx="10241280" cy="411480"/>
           </a:xfrm>
           <a:prstGeom prst="rect">
             <a:avLst/>
@@ -5154,68 +6480,116 @@
           <a:noFill/>
         </p:spPr>
         <p:txBody>
-          <a:bodyPr wrap="none">
+          <a:bodyPr wrap="square">
             <a:spAutoFit/>
           </a:bodyPr>
           <a:lstStyle/>
           <a:p>
+            <a:r>
+              <a:rPr sz="1700" b="0">
+                <a:solidFill>
+                  <a:srgbClr val="AAB8A9"/>
+                </a:solidFill>
+              </a:rPr>
+              <a:t>How the product helps Mentoria scale beyond manual Telegram workflows</a:t>
+            </a:r>
+          </a:p>
+        </p:txBody>
+      </p:sp>
+      <p:sp>
+        <p:nvSpPr>
+          <p:cNvPr id="8" name="TextBox 7"/>
+          <p:cNvSpPr txBox="1"/>
+          <p:nvPr/>
+        </p:nvSpPr>
+        <p:spPr>
+          <a:xfrm>
+            <a:off x="685800" y="2148840"/>
+            <a:ext cx="10469880" cy="4224528"/>
+          </a:xfrm>
+          <a:prstGeom prst="rect">
+            <a:avLst/>
+          </a:prstGeom>
+          <a:noFill/>
+        </p:spPr>
+        <p:txBody>
+          <a:bodyPr wrap="square">
+            <a:spAutoFit/>
+          </a:bodyPr>
+          <a:lstStyle/>
+          <a:p>
             <a:pPr>
               <a:spcAft>
-                <a:spcPts val="800"/>
+                <a:spcPts val="700"/>
               </a:spcAft>
-              <a:defRPr sz="1900">
+              <a:defRPr sz="1800">
                 <a:solidFill>
                   <a:srgbClr val="E6EADA"/>
                 </a:solidFill>
               </a:defRPr>
             </a:pPr>
             <a:r>
-              <a:t>Reduces dependence on Telegram and live-only learning.</a:t>
+              <a:t>Scales async learning: students can study even when they cannot attend live lessons.</a:t>
             </a:r>
           </a:p>
           <a:p>
             <a:pPr>
               <a:spcAft>
-                <a:spcPts val="800"/>
+                <a:spcPts val="700"/>
               </a:spcAft>
-              <a:defRPr sz="1900">
+              <a:defRPr sz="1800">
                 <a:solidFill>
                   <a:srgbClr val="E6EADA"/>
                 </a:solidFill>
               </a:defRPr>
             </a:pPr>
             <a:r>
-              <a:t>Improves student retention through progress, deadlines and personalized next steps.</a:t>
+              <a:t>Centralizes opportunities: courses, deadlines, recommendations and saved items are in one place.</a:t>
             </a:r>
           </a:p>
           <a:p>
             <a:pPr>
               <a:spcAft>
-                <a:spcPts val="800"/>
+                <a:spcPts val="700"/>
               </a:spcAft>
-              <a:defRPr sz="1900">
+              <a:defRPr sz="1800">
                 <a:solidFill>
                   <a:srgbClr val="E6EADA"/>
                 </a:solidFill>
               </a:defRPr>
             </a:pPr>
             <a:r>
-              <a:t>Makes Mentoria look more professional for schools, sponsors and partners.</a:t>
+              <a:t>Improves retention: progress bars, deadlines, AI next steps and CV feedback keep students engaged.</a:t>
             </a:r>
           </a:p>
           <a:p>
             <a:pPr>
               <a:spcAft>
-                <a:spcPts val="800"/>
+                <a:spcPts val="700"/>
               </a:spcAft>
-              <a:defRPr sz="1900">
+              <a:defRPr sz="1800">
                 <a:solidFill>
                   <a:srgbClr val="E6EADA"/>
                 </a:solidFill>
               </a:defRPr>
             </a:pPr>
             <a:r>
-              <a:t>Creates a foundation for future integrations: Supabase/Postgres, Telegram reminders and mentor portal.</a:t>
+              <a:t>Improves professional image: Mentoria can show schools, sponsors and partners a real digital platform.</a:t>
+            </a:r>
+          </a:p>
+          <a:p>
+            <a:pPr>
+              <a:spcAft>
+                <a:spcPts val="700"/>
+              </a:spcAft>
+              <a:defRPr sz="1800">
+                <a:solidFill>
+                  <a:srgbClr val="E6EADA"/>
+                </a:solidFill>
+              </a:defRPr>
+            </a:pPr>
+            <a:r>
+              <a:t>Reduces admin load: admins add opportunities and courses through a panel instead of rebuilding or reposting.</a:t>
             </a:r>
           </a:p>
         </p:txBody>

</xml_diff>

<commit_message>
Translate presentation to Russian
</commit_message>
<xml_diff>
--- a/Mentoria_Compass_Mogger_Presentation.pptx
+++ b/Mentoria_Compass_Mogger_Presentation.pptx
@@ -3194,7 +3194,7 @@
                   <a:srgbClr val="0A0C0B"/>
                 </a:solidFill>
               </a:rPr>
-              <a:t>01 / Project</a:t>
+              <a:t>01 / Проект</a:t>
             </a:r>
           </a:p>
         </p:txBody>
@@ -3260,7 +3260,7 @@
                   <a:srgbClr val="DFFF55"/>
                 </a:solidFill>
               </a:rPr>
-              <a:t>MENTORIA COMPASS / TEAM MOGGER</a:t>
+              <a:t>MENTORIA COMPASS / КОМАНДА MOGGER</a:t>
             </a:r>
           </a:p>
         </p:txBody>
@@ -3326,7 +3326,7 @@
                   <a:srgbClr val="AAB8A9"/>
                 </a:solidFill>
               </a:rPr>
-              <a:t>Full-stack EdTech hub for opportunities, async learning, AI roadmap and CV review</a:t>
+              <a:t>Full-stack EdTech-платформа для возможностей, асинхронного обучения, AI-roadmap и анализа CV</a:t>
             </a:r>
           </a:p>
         </p:txBody>
@@ -3364,7 +3364,7 @@
               </a:defRPr>
             </a:pPr>
             <a:r>
-              <a:t>Team: Mogger</a:t>
+              <a:t>Команда: Mogger</a:t>
             </a:r>
           </a:p>
           <a:p>
@@ -3379,7 +3379,7 @@
               </a:defRPr>
             </a:pPr>
             <a:r>
-              <a:t>Captain: Shabdanov Askar / @LawDirr</a:t>
+              <a:t>Капитан: Шабданов Аскар / @LawDirr</a:t>
             </a:r>
           </a:p>
           <a:p>
@@ -3394,7 +3394,7 @@
               </a:defRPr>
             </a:pPr>
             <a:r>
-              <a:t>Production product: https://mentoria-compass.vercel.app</a:t>
+              <a:t>Готовый продукт: https://mentoria-compass.vercel.app</a:t>
             </a:r>
           </a:p>
           <a:p>
@@ -3409,7 +3409,7 @@
               </a:defRPr>
             </a:pPr>
             <a:r>
-              <a:t>GitHub repository: https://github.com/askarshabdanov1-collab/Mentoria</a:t>
+              <a:t>GitHub-репозиторий: https://github.com/askarshabdanov1-collab/Mentoria</a:t>
             </a:r>
           </a:p>
           <a:p>
@@ -3424,7 +3424,7 @@
               </a:defRPr>
             </a:pPr>
             <a:r>
-              <a:t>Demo accounts: student amina@mentoria.demo / demo123, admin admin@mentoria.demo / admin123</a:t>
+              <a:t>Демо-аккаунты: ученик amina@mentoria.demo / demo123, админ admin@mentoria.demo / admin123</a:t>
             </a:r>
           </a:p>
         </p:txBody>
@@ -3610,7 +3610,7 @@
                   <a:srgbClr val="DFFF55"/>
                 </a:solidFill>
               </a:rPr>
-              <a:t>MENTORIA COMPASS / TEAM MOGGER</a:t>
+              <a:t>MENTORIA COMPASS / КОМАНДА MOGGER</a:t>
             </a:r>
           </a:p>
         </p:txBody>
@@ -3643,7 +3643,7 @@
                   <a:srgbClr val="FFFEF0"/>
                 </a:solidFill>
               </a:rPr>
-              <a:t>What Comes Next</a:t>
+              <a:t>Что дальше</a:t>
             </a:r>
           </a:p>
         </p:txBody>
@@ -3676,7 +3676,7 @@
                   <a:srgbClr val="AAB8A9"/>
                 </a:solidFill>
               </a:rPr>
-              <a:t>Clear path from hackathon MVP to real Mentoria product</a:t>
+              <a:t>Путь от хакатонного MVP к реальному продукту Mentoria</a:t>
             </a:r>
           </a:p>
         </p:txBody>
@@ -3714,7 +3714,7 @@
               </a:defRPr>
             </a:pPr>
             <a:r>
-              <a:t>Connect persistent production database: Supabase or Neon Postgres.</a:t>
+              <a:t>Подключить постоянную production-базу данных: Supabase или Neon Postgres.</a:t>
             </a:r>
           </a:p>
           <a:p>
@@ -3729,7 +3729,7 @@
               </a:defRPr>
             </a:pPr>
             <a:r>
-              <a:t>Add Telegram/email reminders for saved opportunity deadlines.</a:t>
+              <a:t>Добавить Telegram/email-напоминания по дедлайнам сохранённых возможностей.</a:t>
             </a:r>
           </a:p>
           <a:p>
@@ -3744,7 +3744,7 @@
               </a:defRPr>
             </a:pPr>
             <a:r>
-              <a:t>Add mentor portal for uploading lessons, checking assignments and leaving feedback.</a:t>
+              <a:t>Добавить портал менторов для загрузки уроков, проверки заданий и фидбека.</a:t>
             </a:r>
           </a:p>
           <a:p>
@@ -3759,7 +3759,7 @@
               </a:defRPr>
             </a:pPr>
             <a:r>
-              <a:t>Add multilingual interface: Russian, English and Kazakh.</a:t>
+              <a:t>Добавить мультиязычный интерфейс: русский, английский и казахский.</a:t>
             </a:r>
           </a:p>
           <a:p>
@@ -3774,7 +3774,7 @@
               </a:defRPr>
             </a:pPr>
             <a:r>
-              <a:t>Add certificates, leaderboard and advanced roadmap for grades 8, 9, 10 and 11.</a:t>
+              <a:t>Добавить сертификаты, leaderboard и расширенный roadmap для 8, 9, 10 и 11 классов.</a:t>
             </a:r>
           </a:p>
           <a:p>
@@ -3789,7 +3789,7 @@
               </a:defRPr>
             </a:pPr>
             <a:r>
-              <a:t>Add real AI integration for deeper CV and essay review when API keys are available.</a:t>
+              <a:t>Добавить реальную AI-интеграцию для глубокого анализа CV и эссе при наличии API-ключей.</a:t>
             </a:r>
           </a:p>
         </p:txBody>
@@ -3909,7 +3909,7 @@
                   <a:srgbClr val="0A0C0B"/>
                 </a:solidFill>
               </a:rPr>
-              <a:t>02 / Problem</a:t>
+              <a:t>02 / Проблема</a:t>
             </a:r>
           </a:p>
         </p:txBody>
@@ -3975,7 +3975,7 @@
                   <a:srgbClr val="DFFF55"/>
                 </a:solidFill>
               </a:rPr>
-              <a:t>MENTORIA COMPASS / TEAM MOGGER</a:t>
+              <a:t>MENTORIA COMPASS / КОМАНДА MOGGER</a:t>
             </a:r>
           </a:p>
         </p:txBody>
@@ -4008,7 +4008,7 @@
                   <a:srgbClr val="FFFEF0"/>
                 </a:solidFill>
               </a:rPr>
-              <a:t>Why Mentoria Needs a Platform</a:t>
+              <a:t>Зачем Mentoria нужна платформа</a:t>
             </a:r>
           </a:p>
         </p:txBody>
@@ -4041,7 +4041,7 @@
                   <a:srgbClr val="AAB8A9"/>
                 </a:solidFill>
               </a:rPr>
-              <a:t>Telegram and live calls are not enough when the organization grows</a:t>
+              <a:t>Telegram и живые занятия перестают масштабироваться, когда организация растёт</a:t>
             </a:r>
           </a:p>
         </p:txBody>
@@ -4079,7 +4079,7 @@
               </a:defRPr>
             </a:pPr>
             <a:r>
-              <a:t>Students miss live lessons because of school, exams, time zones, internet access and personal schedules.</a:t>
+              <a:t>Ученики пропускают живые уроки из-за школы, экзаменов, часовых поясов, интернета и личного расписания.</a:t>
             </a:r>
           </a:p>
           <a:p>
@@ -4094,7 +4094,7 @@
               </a:defRPr>
             </a:pPr>
             <a:r>
-              <a:t>Opportunities are scattered across websites, Telegram channels, chats and documents.</a:t>
+              <a:t>Возможности разбросаны по сайтам, Telegram-каналам, чатам и документам.</a:t>
             </a:r>
           </a:p>
           <a:p>
@@ -4109,7 +4109,7 @@
               </a:defRPr>
             </a:pPr>
             <a:r>
-              <a:t>Students do not know which competitions, scholarships or programs match their grade, interests and goals.</a:t>
+              <a:t>Ученикам сложно понять, какие конкурсы, стипендии и программы подходят их классу, интересам и целям.</a:t>
             </a:r>
           </a:p>
           <a:p>
@@ -4124,7 +4124,7 @@
               </a:defRPr>
             </a:pPr>
             <a:r>
-              <a:t>Mentoria admins need to add courses and opportunities without rebuilding the website or posting manually.</a:t>
+              <a:t>Администраторам Mentoria нужно добавлять курсы и возможности без пересборки сайта и ручных постов.</a:t>
             </a:r>
           </a:p>
           <a:p>
@@ -4139,7 +4139,7 @@
               </a:defRPr>
             </a:pPr>
             <a:r>
-              <a:t>Partners, schools and sponsors need to see a professional scalable product, not only a chat community.</a:t>
+              <a:t>Партнёрам, школам и спонсорам важно видеть профессиональный масштабируемый продукт, а не только чат.</a:t>
             </a:r>
           </a:p>
         </p:txBody>
@@ -4259,7 +4259,7 @@
                   <a:srgbClr val="0A0C0B"/>
                 </a:solidFill>
               </a:rPr>
-              <a:t>03 / Audience</a:t>
+              <a:t>03 / Аудитория</a:t>
             </a:r>
           </a:p>
         </p:txBody>
@@ -4325,7 +4325,7 @@
                   <a:srgbClr val="DFFF55"/>
                 </a:solidFill>
               </a:rPr>
-              <a:t>MENTORIA COMPASS / TEAM MOGGER</a:t>
+              <a:t>MENTORIA COMPASS / КОМАНДА MOGGER</a:t>
             </a:r>
           </a:p>
         </p:txBody>
@@ -4358,7 +4358,7 @@
                   <a:srgbClr val="FFFEF0"/>
                 </a:solidFill>
               </a:rPr>
-              <a:t>Who the Product Is For</a:t>
+              <a:t>Для кого создан продукт</a:t>
             </a:r>
           </a:p>
         </p:txBody>
@@ -4391,7 +4391,7 @@
                   <a:srgbClr val="AAB8A9"/>
                 </a:solidFill>
               </a:rPr>
-              <a:t>Students in grades 8-11 preparing for growth beyond school</a:t>
+              <a:t>Ученики 8-11 классов, которые хотят развиваться за пределами школы</a:t>
             </a:r>
           </a:p>
         </p:txBody>
@@ -4429,7 +4429,7 @@
               </a:defRPr>
             </a:pPr>
             <a:r>
-              <a:t>Students from Kazakhstan and other countries who want academic and extracurricular opportunities.</a:t>
+              <a:t>Ученики из Казахстана и других стран, которые ищут академические и внеклассные возможности.</a:t>
             </a:r>
           </a:p>
           <a:p>
@@ -4444,7 +4444,7 @@
               </a:defRPr>
             </a:pPr>
             <a:r>
-              <a:t>Students preparing for university admissions, IELTS/SAT, scholarships and international programs.</a:t>
+              <a:t>Ученики, готовящиеся к поступлению, IELTS/SAT, стипендиям и международным программам.</a:t>
             </a:r>
           </a:p>
           <a:p>
@@ -4459,7 +4459,7 @@
               </a:defRPr>
             </a:pPr>
             <a:r>
-              <a:t>Students interested in STEM, business, finance, social impact, programming, science and English.</a:t>
+              <a:t>Ученики, которым интересны STEM, бизнес, финансы, social impact, программирование, наука и английский.</a:t>
             </a:r>
           </a:p>
           <a:p>
@@ -4474,7 +4474,7 @@
               </a:defRPr>
             </a:pPr>
             <a:r>
-              <a:t>Mentoria admins and mentors who need one place to manage learning content and student progress.</a:t>
+              <a:t>Администраторы и менторы Mentoria, которым нужно управлять контентом и прогрессом учеников в одном месте.</a:t>
             </a:r>
           </a:p>
         </p:txBody>
@@ -4594,7 +4594,7 @@
                   <a:srgbClr val="0A0C0B"/>
                 </a:solidFill>
               </a:rPr>
-              <a:t>04 / Solution</a:t>
+              <a:t>04 / Решение</a:t>
             </a:r>
           </a:p>
         </p:txBody>
@@ -4660,7 +4660,7 @@
                   <a:srgbClr val="DFFF55"/>
                 </a:solidFill>
               </a:rPr>
-              <a:t>MENTORIA COMPASS / TEAM MOGGER</a:t>
+              <a:t>MENTORIA COMPASS / КОМАНДА MOGGER</a:t>
             </a:r>
           </a:p>
         </p:txBody>
@@ -4693,7 +4693,7 @@
                   <a:srgbClr val="FFFEF0"/>
                 </a:solidFill>
               </a:rPr>
-              <a:t>What Mentoria Compass Does</a:t>
+              <a:t>Что делает Mentoria Compass</a:t>
             </a:r>
           </a:p>
         </p:txBody>
@@ -4726,7 +4726,7 @@
                   <a:srgbClr val="AAB8A9"/>
                 </a:solidFill>
               </a:rPr>
-              <a:t>One product connecting discovery, learning, progress and applications</a:t>
+              <a:t>Один продукт, который соединяет поиск возможностей, обучение, прогресс и заявки</a:t>
             </a:r>
           </a:p>
         </p:txBody>
@@ -4764,7 +4764,7 @@
               </a:defRPr>
             </a:pPr>
             <a:r>
-              <a:t>Personal registration and student cabinet with saved opportunities, learning progress and deadlines.</a:t>
+              <a:t>Регистрация и личный кабинет ученика с сохранёнными возможностями, прогрессом и дедлайнами.</a:t>
             </a:r>
           </a:p>
           <a:p>
@@ -4779,7 +4779,7 @@
               </a:defRPr>
             </a:pPr>
             <a:r>
-              <a:t>Opportunity catalog with search, filters and match score based on profile tags.</a:t>
+              <a:t>Каталог возможностей с поиском, фильтрами и match score на основе профиля.</a:t>
             </a:r>
           </a:p>
           <a:p>
@@ -4794,7 +4794,7 @@
               </a:defRPr>
             </a:pPr>
             <a:r>
-              <a:t>Async courses with lessons, video placeholders, mini tasks and progress tracking.</a:t>
+              <a:t>Асинхронные курсы с уроками, видео-плейсхолдерами, мини-заданиями и отслеживанием прогресса.</a:t>
             </a:r>
           </a:p>
           <a:p>
@@ -4809,7 +4809,7 @@
               </a:defRPr>
             </a:pPr>
             <a:r>
-              <a:t>AI Analysis that produces readiness score, risks, strengths and a weekly action plan.</a:t>
+              <a:t>AI Analysis: readiness score, риски, сильные стороны и недельный план действий.</a:t>
             </a:r>
           </a:p>
           <a:p>
@@ -4824,7 +4824,7 @@
               </a:defRPr>
             </a:pPr>
             <a:r>
-              <a:t>Admin panel for publishing opportunities and courses through the backend API.</a:t>
+              <a:t>Админ-панель для публикации возможностей и курсов через backend API.</a:t>
             </a:r>
           </a:p>
         </p:txBody>
@@ -4944,7 +4944,7 @@
                   <a:srgbClr val="0A0C0B"/>
                 </a:solidFill>
               </a:rPr>
-              <a:t>05 / Journey</a:t>
+              <a:t>05 / Сценарий</a:t>
             </a:r>
           </a:p>
         </p:txBody>
@@ -5010,7 +5010,7 @@
                   <a:srgbClr val="DFFF55"/>
                 </a:solidFill>
               </a:rPr>
-              <a:t>MENTORIA COMPASS / TEAM MOGGER</a:t>
+              <a:t>MENTORIA COMPASS / КОМАНДА MOGGER</a:t>
             </a:r>
           </a:p>
         </p:txBody>
@@ -5043,7 +5043,7 @@
                   <a:srgbClr val="FFFEF0"/>
                 </a:solidFill>
               </a:rPr>
-              <a:t>Main User Journey</a:t>
+              <a:t>Основной пользовательский путь</a:t>
             </a:r>
           </a:p>
         </p:txBody>
@@ -5076,7 +5076,7 @@
                   <a:srgbClr val="AAB8A9"/>
                 </a:solidFill>
               </a:rPr>
-              <a:t>Designed to be shown clearly in a 4-minute demo</a:t>
+              <a:t>Сценарий удобно показать в 4-минутном демо</a:t>
             </a:r>
           </a:p>
         </p:txBody>
@@ -5114,7 +5114,7 @@
               </a:defRPr>
             </a:pPr>
             <a:r>
-              <a:t>Student logs in or registers and fills profile: grade, country, school, English level, interests and goals.</a:t>
+              <a:t>Ученик регистрируется или входит и заполняет профиль: класс, страна, школа, английский, интересы и цели.</a:t>
             </a:r>
           </a:p>
           <a:p>
@@ -5129,7 +5129,7 @@
               </a:defRPr>
             </a:pPr>
             <a:r>
-              <a:t>Compass dashboard recommends opportunities and courses with profile match scores.</a:t>
+              <a:t>Compass dashboard рекомендует возможности и курсы с match score.</a:t>
             </a:r>
           </a:p>
           <a:p>
@@ -5144,7 +5144,7 @@
               </a:defRPr>
             </a:pPr>
             <a:r>
-              <a:t>Student saves an opportunity, sees deadline pressure and starts a relevant course.</a:t>
+              <a:t>Ученик сохраняет возможность, видит дедлайн и начинает подходящий курс.</a:t>
             </a:r>
           </a:p>
           <a:p>
@@ -5159,7 +5159,7 @@
               </a:defRPr>
             </a:pPr>
             <a:r>
-              <a:t>Student completes a lesson and the personal cabinet updates progress automatically.</a:t>
+              <a:t>Ученик завершает урок, а личный кабинет автоматически обновляет прогресс.</a:t>
             </a:r>
           </a:p>
           <a:p>
@@ -5174,7 +5174,7 @@
               </a:defRPr>
             </a:pPr>
             <a:r>
-              <a:t>Student opens AI Analysis and gets next actions for applications and learning.</a:t>
+              <a:t>Ученик открывает AI Analysis и получает следующие шаги для заявок и обучения.</a:t>
             </a:r>
           </a:p>
           <a:p>
@@ -5189,7 +5189,7 @@
               </a:defRPr>
             </a:pPr>
             <a:r>
-              <a:t>Admin logs in and adds a new opportunity, which appears immediately in the catalog.</a:t>
+              <a:t>Админ входит и добавляет новую возможность, которая сразу появляется в каталоге.</a:t>
             </a:r>
           </a:p>
         </p:txBody>
@@ -5375,7 +5375,7 @@
                   <a:srgbClr val="DFFF55"/>
                 </a:solidFill>
               </a:rPr>
-              <a:t>MENTORIA COMPASS / TEAM MOGGER</a:t>
+              <a:t>MENTORIA COMPASS / КОМАНДА MOGGER</a:t>
             </a:r>
           </a:p>
         </p:txBody>
@@ -5408,7 +5408,7 @@
                   <a:srgbClr val="FFFEF0"/>
                 </a:solidFill>
               </a:rPr>
-              <a:t>AI Roadmap and Recommendations</a:t>
+              <a:t>AI-roadmap и рекомендации</a:t>
             </a:r>
           </a:p>
         </p:txBody>
@@ -5441,7 +5441,7 @@
                   <a:srgbClr val="AAB8A9"/>
                 </a:solidFill>
               </a:rPr>
-              <a:t>Practical analysis that works instantly without external API keys</a:t>
+              <a:t>Практичный анализ, который работает сразу без внешних API-ключей</a:t>
             </a:r>
           </a:p>
         </p:txBody>
@@ -5479,7 +5479,7 @@
               </a:defRPr>
             </a:pPr>
             <a:r>
-              <a:t>Readiness score is calculated from profile completeness, saved opportunities, course progress and deadline urgency.</a:t>
+              <a:t>Readiness score считается по полноте профиля, сохранённым возможностям, прогрессу курсов и срочности дедлайнов.</a:t>
             </a:r>
           </a:p>
           <a:p>
@@ -5494,7 +5494,7 @@
               </a:defRPr>
             </a:pPr>
             <a:r>
-              <a:t>The system detects risks: missing saved opportunities, low progress, close deadlines and weak portfolio focus.</a:t>
+              <a:t>Система находит риски: нет сохранённых возможностей, низкий прогресс, близкие дедлайны, слабый фокус на портфолио.</a:t>
             </a:r>
           </a:p>
           <a:p>
@@ -5509,7 +5509,7 @@
               </a:defRPr>
             </a:pPr>
             <a:r>
-              <a:t>Students receive concrete next actions, not generic advice.</a:t>
+              <a:t>Ученик получает конкретные следующие действия, а не общие советы.</a:t>
             </a:r>
           </a:p>
           <a:p>
@@ -5524,7 +5524,7 @@
               </a:defRPr>
             </a:pPr>
             <a:r>
-              <a:t>Weekly plan turns recommendations into daily tasks: choose opportunity, finish lesson, draft answer, ask mentor, submit.</a:t>
+              <a:t>Недельный план превращает рекомендации в задачи: выбрать возможность, пройти урок, написать ответ, спросить ментора, отправить заявку.</a:t>
             </a:r>
           </a:p>
           <a:p>
@@ -5539,7 +5539,7 @@
               </a:defRPr>
             </a:pPr>
             <a:r>
-              <a:t>This helps Mentoria increase retention because students always know the next step.</a:t>
+              <a:t>Это повышает удержание: ученик всегда понимает, что делать дальше.</a:t>
             </a:r>
           </a:p>
         </p:txBody>
@@ -5725,7 +5725,7 @@
                   <a:srgbClr val="DFFF55"/>
                 </a:solidFill>
               </a:rPr>
-              <a:t>MENTORIA COMPASS / TEAM MOGGER</a:t>
+              <a:t>MENTORIA COMPASS / КОМАНДА MOGGER</a:t>
             </a:r>
           </a:p>
         </p:txBody>
@@ -5758,7 +5758,7 @@
                   <a:srgbClr val="FFFEF0"/>
                 </a:solidFill>
               </a:rPr>
-              <a:t>CV Review: Find Gaps and Improve</a:t>
+              <a:t>CV Review: найти дыры и улучшить</a:t>
             </a:r>
           </a:p>
         </p:txBody>
@@ -5791,7 +5791,7 @@
                   <a:srgbClr val="AAB8A9"/>
                 </a:solidFill>
               </a:rPr>
-              <a:t>Students can upload or paste a CV and receive application-focused feedback</a:t>
+              <a:t>Ученик может загрузить или вставить CV и получить фидбек под заявки</a:t>
             </a:r>
           </a:p>
         </p:txBody>
@@ -5829,7 +5829,7 @@
               </a:defRPr>
             </a:pPr>
             <a:r>
-              <a:t>The platform checks whether the CV has contact details, education, projects, skills, awards and links.</a:t>
+              <a:t>Платформа проверяет, есть ли контакты, образование, проекты, навыки, достижения и ссылки.</a:t>
             </a:r>
           </a:p>
           <a:p>
@@ -5844,7 +5844,7 @@
               </a:defRPr>
             </a:pPr>
             <a:r>
-              <a:t>It detects weak evidence: no numbers, passive bullets, missing portfolio links and unclear achievements.</a:t>
+              <a:t>Система находит слабые места: нет цифр, пассивные bullets, нет portfolio/GitHub-ссылок, неясные достижения.</a:t>
             </a:r>
           </a:p>
           <a:p>
@@ -5859,7 +5859,7 @@
               </a:defRPr>
             </a:pPr>
             <a:r>
-              <a:t>Students get a CV readiness score and prioritized gaps to fix first.</a:t>
+              <a:t>Ученик получает CV readiness score и приоритетные дыры, которые нужно закрыть первыми.</a:t>
             </a:r>
           </a:p>
           <a:p>
@@ -5874,7 +5874,7 @@
               </a:defRPr>
             </a:pPr>
             <a:r>
-              <a:t>The tool suggests concrete improvements: stronger summary, quantified impact, project section and rewritten bullets.</a:t>
+              <a:t>Инструмент предлагает конкретные улучшения: сильный summary, измеримый impact, проектный раздел и переписанные bullets.</a:t>
             </a:r>
           </a:p>
           <a:p>
@@ -5889,7 +5889,7 @@
               </a:defRPr>
             </a:pPr>
             <a:r>
-              <a:t>CV reviews are saved in the student account so progress can be revisited later.</a:t>
+              <a:t>Анализы CV сохраняются в аккаунте ученика, чтобы можно было вернуться к прогрессу позже.</a:t>
             </a:r>
           </a:p>
         </p:txBody>
@@ -6009,7 +6009,7 @@
                   <a:srgbClr val="0A0C0B"/>
                 </a:solidFill>
               </a:rPr>
-              <a:t>08 / Technology</a:t>
+              <a:t>08 / Технологии</a:t>
             </a:r>
           </a:p>
         </p:txBody>
@@ -6075,7 +6075,7 @@
                   <a:srgbClr val="DFFF55"/>
                 </a:solidFill>
               </a:rPr>
-              <a:t>MENTORIA COMPASS / TEAM MOGGER</a:t>
+              <a:t>MENTORIA COMPASS / КОМАНДА MOGGER</a:t>
             </a:r>
           </a:p>
         </p:txBody>
@@ -6108,7 +6108,7 @@
                   <a:srgbClr val="FFFEF0"/>
                 </a:solidFill>
               </a:rPr>
-              <a:t>Technical Architecture</a:t>
+              <a:t>Техническая архитектура</a:t>
             </a:r>
           </a:p>
         </p:txBody>
@@ -6141,7 +6141,7 @@
                   <a:srgbClr val="AAB8A9"/>
                 </a:solidFill>
               </a:rPr>
-              <a:t>Full-stack app deployed to production</a:t>
+              <a:t>Full-stack приложение, задеплоенное в production</a:t>
             </a:r>
           </a:p>
         </p:txBody>
@@ -6179,7 +6179,7 @@
               </a:defRPr>
             </a:pPr>
             <a:r>
-              <a:t>Frontend: React + Vite dashboard with responsive navigation and product-style UI.</a:t>
+              <a:t>Frontend: React + Vite dashboard с адаптивной навигацией и продуктовым UI.</a:t>
             </a:r>
           </a:p>
           <a:p>
@@ -6194,7 +6194,7 @@
               </a:defRPr>
             </a:pPr>
             <a:r>
-              <a:t>Backend: Node API with auth, user profile, progress, saved items, admin content and CV analysis routes.</a:t>
+              <a:t>Backend: Node API с auth, профилем, прогрессом, сохранёнными элементами, админ-контентом и CV analysis routes.</a:t>
             </a:r>
           </a:p>
           <a:p>
@@ -6209,7 +6209,7 @@
               </a:defRPr>
             </a:pPr>
             <a:r>
-              <a:t>Authentication: registration, login, logout and bearer-token sessions.</a:t>
+              <a:t>Аутентификация: регистрация, вход, выход и bearer-token sessions.</a:t>
             </a:r>
           </a:p>
           <a:p>
@@ -6224,7 +6224,7 @@
               </a:defRPr>
             </a:pPr>
             <a:r>
-              <a:t>Deployment: Vercel production app connected to GitHub repository.</a:t>
+              <a:t>Deployment: production на Vercel, подключённый к GitHub-репозиторию.</a:t>
             </a:r>
           </a:p>
           <a:p>
@@ -6239,7 +6239,7 @@
               </a:defRPr>
             </a:pPr>
             <a:r>
-              <a:t>Current storage: JSON seed/serverless storage for hackathon delivery; next production step is Supabase/Neon Postgres.</a:t>
+              <a:t>Текущее хранение: JSON seed/serverless storage для хакатона; следующий шаг для production — Supabase/Neon Postgres.</a:t>
             </a:r>
           </a:p>
         </p:txBody>
@@ -6425,7 +6425,7 @@
                   <a:srgbClr val="DFFF55"/>
                 </a:solidFill>
               </a:rPr>
-              <a:t>MENTORIA COMPASS / TEAM MOGGER</a:t>
+              <a:t>MENTORIA COMPASS / КОМАНДА MOGGER</a:t>
             </a:r>
           </a:p>
         </p:txBody>
@@ -6458,7 +6458,7 @@
                   <a:srgbClr val="FFFEF0"/>
                 </a:solidFill>
               </a:rPr>
-              <a:t>Impact for Mentoria</a:t>
+              <a:t>Влияние для Mentoria</a:t>
             </a:r>
           </a:p>
         </p:txBody>
@@ -6491,7 +6491,7 @@
                   <a:srgbClr val="AAB8A9"/>
                 </a:solidFill>
               </a:rPr>
-              <a:t>How the product helps Mentoria scale beyond manual Telegram workflows</a:t>
+              <a:t>Как продукт помогает Mentoria масштабироваться за пределы Telegram</a:t>
             </a:r>
           </a:p>
         </p:txBody>
@@ -6529,7 +6529,7 @@
               </a:defRPr>
             </a:pPr>
             <a:r>
-              <a:t>Scales async learning: students can study even when they cannot attend live lessons.</a:t>
+              <a:t>Масштабирует асинхронное обучение: ученики могут учиться даже без live-занятий.</a:t>
             </a:r>
           </a:p>
           <a:p>
@@ -6544,7 +6544,7 @@
               </a:defRPr>
             </a:pPr>
             <a:r>
-              <a:t>Centralizes opportunities: courses, deadlines, recommendations and saved items are in one place.</a:t>
+              <a:t>Централизует возможности: курсы, дедлайны, рекомендации и сохранённые элементы находятся в одном месте.</a:t>
             </a:r>
           </a:p>
           <a:p>
@@ -6559,7 +6559,7 @@
               </a:defRPr>
             </a:pPr>
             <a:r>
-              <a:t>Improves retention: progress bars, deadlines, AI next steps and CV feedback keep students engaged.</a:t>
+              <a:t>Повышает удержание: progress bars, дедлайны, AI next steps и CV feedback удерживают вовлечённость.</a:t>
             </a:r>
           </a:p>
           <a:p>
@@ -6574,7 +6574,7 @@
               </a:defRPr>
             </a:pPr>
             <a:r>
-              <a:t>Improves professional image: Mentoria can show schools, sponsors and partners a real digital platform.</a:t>
+              <a:t>Усиливает профессиональный имидж: Mentoria может показать школам, спонсорам и партнёрам реальную платформу.</a:t>
             </a:r>
           </a:p>
           <a:p>
@@ -6589,7 +6589,7 @@
               </a:defRPr>
             </a:pPr>
             <a:r>
-              <a:t>Reduces admin load: admins add opportunities and courses through a panel instead of rebuilding or reposting.</a:t>
+              <a:t>Снижает нагрузку на админов: возможности и курсы добавляются через панель, без пересборки и ручных постов.</a:t>
             </a:r>
           </a:p>
         </p:txBody>

</xml_diff>